<commit_message>
Explain the why, not just the what: framing + alternatives
- README: add a Problem framing section and a Design decisions &
  alternatives-considered table (agent vs RAG, calculator vs LLM
  math, EUR-Lex vs ifrs.org, flash-lite vs gemini-3.x, section vs
  fixed chunking, FAISS vs hosted). Fix stale usage commands.
- Slides: add a Design decisions & alternatives-rejected slide
  (13 total).
Addresses the rubric on design rationale.
</commit_message>
<xml_diff>
--- a/slides/presentation.pptx
+++ b/slides/presentation.pptx
@@ -17,9 +17,10 @@
     <p:sldId id="265" r:id="rId11"/>
     <p:sldId id="266" r:id="rId12"/>
     <p:sldId id="267" r:id="rId13"/>
+    <p:sldId id="268" r:id="rId14"/>
   </p:sldIdLst>
   <p:notesMasterIdLst>
-    <p:notesMasterId r:id="rId14"/>
+    <p:notesMasterId r:id="rId15"/>
   </p:notesMasterIdLst>
   <p:sldSz cx="12192000" cy="6858000"/>
   <p:notesSz cx="6858000" cy="12192000"/>
@@ -801,6 +802,94 @@
             <a:fld id="{F7021451-1387-4CA6-816F-3879F97B5CBC}" type="slidenum">
               <a:rPr lang="en-US"/>
               <a:t>12</a:t>
+            </a:fld>
+            <a:endParaRPr lang="en-US"/>
+          </a:p>
+        </p:txBody>
+      </p:sp>
+    </p:spTree>
+    <p:extLst>
+      <p:ext uri="{BB962C8B-B14F-4D97-AF65-F5344CB8AC3E}">
+        <p14:creationId xmlns:p14="http://schemas.microsoft.com/office/powerpoint/2010/main" val="1024086991"/>
+      </p:ext>
+    </p:extLst>
+  </p:cSld>
+  <p:clrMapOvr>
+    <a:masterClrMapping/>
+  </p:clrMapOvr>
+</p:notes>
+</file>
+
+<file path=ppt/notesSlides/notesSlide13.xml><?xml version="1.0" encoding="utf-8"?>
+<p:notes xmlns:a="http://schemas.openxmlformats.org/drawingml/2006/main" xmlns:r="http://schemas.openxmlformats.org/officeDocument/2006/relationships" xmlns:p="http://schemas.openxmlformats.org/presentationml/2006/main">
+  <p:cSld>
+    <p:spTree>
+      <p:nvGrpSpPr>
+        <p:cNvPr id="1" name=""/>
+        <p:cNvGrpSpPr/>
+        <p:nvPr/>
+      </p:nvGrpSpPr>
+      <p:grpSpPr>
+        <a:xfrm>
+          <a:off x="0" y="0"/>
+          <a:ext cx="0" cy="0"/>
+          <a:chOff x="0" y="0"/>
+          <a:chExt cx="0" cy="0"/>
+        </a:xfrm>
+      </p:grpSpPr>
+      <p:sp>
+        <p:nvSpPr>
+          <p:cNvPr id="2" name="Slide Image Placeholder 1"/>
+          <p:cNvSpPr>
+            <a:spLocks noGrp="1" noRot="1" noChangeAspect="1"/>
+          </p:cNvSpPr>
+          <p:nvPr>
+            <p:ph type="sldImg"/>
+          </p:nvPr>
+        </p:nvSpPr>
+        <p:spPr/>
+      </p:sp>
+      <p:sp>
+        <p:nvSpPr>
+          <p:cNvPr id="3" name="Notes Placeholder 2"/>
+          <p:cNvSpPr>
+            <a:spLocks noGrp="1"/>
+          </p:cNvSpPr>
+          <p:nvPr>
+            <p:ph type="body" idx="1"/>
+          </p:nvPr>
+        </p:nvSpPr>
+        <p:spPr/>
+        <p:txBody>
+          <a:bodyPr/>
+          <a:lstStyle/>
+          <a:p>
+            <a:r>
+              <a:rPr lang="en-US" dirty="0"/>
+              <a:t/>
+            </a:r>
+            <a:endParaRPr lang="en-US" dirty="0"/>
+          </a:p>
+        </p:txBody>
+      </p:sp>
+      <p:sp>
+        <p:nvSpPr>
+          <p:cNvPr id="4" name="Slide Number Placeholder 3"/>
+          <p:cNvSpPr>
+            <a:spLocks noGrp="1"/>
+          </p:cNvSpPr>
+          <p:nvPr>
+            <p:ph type="sldNum" sz="quarter" idx="10"/>
+          </p:nvPr>
+        </p:nvSpPr>
+        <p:spPr/>
+        <p:txBody>
+          <a:bodyPr/>
+          <a:lstStyle/>
+          <a:p>
+            <a:fld id="{F7021451-1387-4CA6-816F-3879F97B5CBC}" type="slidenum">
+              <a:rPr lang="en-US"/>
+              <a:t>13</a:t>
             </a:fld>
             <a:endParaRPr lang="en-US"/>
           </a:p>
@@ -2168,7 +2257,7 @@
                 <a:ea typeface="Georgia" pitchFamily="34" charset="-122"/>
                 <a:cs typeface="Georgia" pitchFamily="34" charset="-120"/>
               </a:rPr>
-              <a:t>Demo: tool chaining in one answer</a:t>
+              <a:t>Reading the metrics honestly</a:t>
             </a:r>
             <a:endParaRPr lang="en-US" sz="3000" dirty="0"/>
           </a:p>
@@ -2176,53 +2265,14 @@
       </p:sp>
       <p:sp>
         <p:nvSpPr>
-          <p:cNvPr id="3" name="Text 1"/>
-          <p:cNvSpPr/>
-          <p:nvPr/>
-        </p:nvSpPr>
-        <p:spPr>
-          <a:xfrm>
-            <a:off x="640080" y="1325880"/>
-            <a:ext cx="10881360" cy="731520"/>
-          </a:xfrm>
-          <a:prstGeom prst="rect">
-            <a:avLst/>
-          </a:prstGeom>
-          <a:noFill/>
-          <a:ln/>
-        </p:spPr>
-        <p:txBody>
-          <a:bodyPr wrap="square" rtlCol="0" anchor="ctr"/>
-          <a:lstStyle/>
-          <a:p>
-            <a:pPr indent="0" marL="0">
-              <a:buNone/>
-            </a:pPr>
-            <a:r>
-              <a:rPr lang="en-US" sz="1600" i="1" dirty="0">
-                <a:solidFill>
-                  <a:srgbClr val="1E2761"/>
-                </a:solidFill>
-                <a:latin typeface="Calibri" pitchFamily="34" charset="0"/>
-                <a:ea typeface="Calibri" pitchFamily="34" charset="-122"/>
-                <a:cs typeface="Calibri" pitchFamily="34" charset="-120"/>
-              </a:rPr>
-              <a:t>"A machine costs €120,000, residual €20,000, useful life 8 years. Annual depreciation, and which standard?"</a:t>
-            </a:r>
-            <a:endParaRPr lang="en-US" sz="1600" dirty="0"/>
-          </a:p>
-        </p:txBody>
-      </p:sp>
-      <p:sp>
-        <p:nvSpPr>
-          <p:cNvPr id="4" name="Shape 2"/>
-          <p:cNvSpPr/>
-          <p:nvPr/>
-        </p:nvSpPr>
-        <p:spPr>
-          <a:xfrm>
-            <a:off x="640080" y="2240280"/>
-            <a:ext cx="10881360" cy="1097280"/>
+          <p:cNvPr id="3" name="Shape 1"/>
+          <p:cNvSpPr/>
+          <p:nvPr/>
+        </p:nvSpPr>
+        <p:spPr>
+          <a:xfrm>
+            <a:off x="640080" y="1463040"/>
+            <a:ext cx="10881360" cy="1828800"/>
           </a:xfrm>
           <a:prstGeom prst="rect">
             <a:avLst/>
@@ -2247,14 +2297,14 @@
       </p:sp>
       <p:sp>
         <p:nvSpPr>
-          <p:cNvPr id="5" name="Text 3"/>
-          <p:cNvSpPr/>
-          <p:nvPr/>
-        </p:nvSpPr>
-        <p:spPr>
-          <a:xfrm>
-            <a:off x="914400" y="2377440"/>
-            <a:ext cx="3017520" cy="822960"/>
+          <p:cNvPr id="4" name="Text 2"/>
+          <p:cNvSpPr/>
+          <p:nvPr/>
+        </p:nvSpPr>
+        <p:spPr>
+          <a:xfrm>
+            <a:off x="914400" y="1645920"/>
+            <a:ext cx="10332720" cy="457200"/>
           </a:xfrm>
           <a:prstGeom prst="rect">
             <a:avLst/>
@@ -2278,7 +2328,7 @@
                 <a:ea typeface="Georgia" pitchFamily="34" charset="-122"/>
                 <a:cs typeface="Georgia" pitchFamily="34" charset="-120"/>
               </a:rPr>
-              <a:t>1 · search_standards</a:t>
+              <a:t>Why overlap scores look low even when answers are correct</a:t>
             </a:r>
             <a:endParaRPr lang="en-US" sz="1700" dirty="0"/>
           </a:p>
@@ -2286,14 +2336,14 @@
       </p:sp>
       <p:sp>
         <p:nvSpPr>
-          <p:cNvPr id="6" name="Text 4"/>
-          <p:cNvSpPr/>
-          <p:nvPr/>
-        </p:nvSpPr>
-        <p:spPr>
-          <a:xfrm>
-            <a:off x="3931920" y="2377440"/>
-            <a:ext cx="7315200" cy="822960"/>
+          <p:cNvPr id="5" name="Text 3"/>
+          <p:cNvSpPr/>
+          <p:nvPr/>
+        </p:nvSpPr>
+        <p:spPr>
+          <a:xfrm>
+            <a:off x="914400" y="2148840"/>
+            <a:ext cx="10332720" cy="1005840"/>
           </a:xfrm>
           <a:prstGeom prst="rect">
             <a:avLst/>
@@ -2309,7 +2359,7 @@
               <a:buNone/>
             </a:pPr>
             <a:r>
-              <a:rPr lang="en-US" sz="1450" dirty="0">
+              <a:rPr lang="en-US" sz="1500" dirty="0">
                 <a:solidFill>
                   <a:srgbClr val="16203F"/>
                 </a:solidFill>
@@ -2317,28 +2367,28 @@
                 <a:ea typeface="Calibri" pitchFamily="34" charset="-122"/>
                 <a:cs typeface="Calibri" pitchFamily="34" charset="-120"/>
               </a:rPr>
-              <a:t>Finds IAS 16 — depreciable amount allocated over useful life (¶50, 53, 62).</a:t>
-            </a:r>
-            <a:endParaRPr lang="en-US" sz="1450" dirty="0"/>
-          </a:p>
-        </p:txBody>
-      </p:sp>
-      <p:sp>
-        <p:nvSpPr>
-          <p:cNvPr id="7" name="Shape 5"/>
-          <p:cNvSpPr/>
-          <p:nvPr/>
-        </p:nvSpPr>
-        <p:spPr>
-          <a:xfrm>
-            <a:off x="640080" y="3520440"/>
-            <a:ext cx="10881360" cy="1097280"/>
+              <a:t>Reference answers are one line; the agent gives a full, cited explanation. ROUGE/BLEU reward brevity and exact wording, so extra correct words lower the score.</a:t>
+            </a:r>
+            <a:endParaRPr lang="en-US" sz="1500" dirty="0"/>
+          </a:p>
+        </p:txBody>
+      </p:sp>
+      <p:sp>
+        <p:nvSpPr>
+          <p:cNvPr id="6" name="Shape 4"/>
+          <p:cNvSpPr/>
+          <p:nvPr/>
+        </p:nvSpPr>
+        <p:spPr>
+          <a:xfrm>
+            <a:off x="640080" y="3474720"/>
+            <a:ext cx="5303520" cy="2468880"/>
           </a:xfrm>
           <a:prstGeom prst="rect">
             <a:avLst/>
           </a:prstGeom>
           <a:solidFill>
-            <a:srgbClr val="F4F7FB"/>
+            <a:srgbClr val="FFFFFF"/>
           </a:solidFill>
           <a:ln w="12700">
             <a:solidFill>
@@ -2357,14 +2407,14 @@
       </p:sp>
       <p:sp>
         <p:nvSpPr>
-          <p:cNvPr id="8" name="Text 6"/>
+          <p:cNvPr id="7" name="Text 5"/>
           <p:cNvSpPr/>
           <p:nvPr/>
         </p:nvSpPr>
         <p:spPr>
           <a:xfrm>
             <a:off x="914400" y="3657600"/>
-            <a:ext cx="3017520" cy="822960"/>
+            <a:ext cx="4754880" cy="365760"/>
           </a:xfrm>
           <a:prstGeom prst="rect">
             <a:avLst/>
@@ -2380,17 +2430,56 @@
               <a:buNone/>
             </a:pPr>
             <a:r>
-              <a:rPr lang="en-US" sz="1700" b="1" dirty="0">
+              <a:rPr lang="en-US" sz="1300" dirty="0">
                 <a:solidFill>
-                  <a:srgbClr val="1E2761"/>
+                  <a:srgbClr val="5A6275"/>
+                </a:solidFill>
+                <a:latin typeface="Calibri" pitchFamily="34" charset="0"/>
+                <a:ea typeface="Calibri" pitchFamily="34" charset="-122"/>
+                <a:cs typeface="Calibri" pitchFamily="34" charset="-120"/>
+              </a:rPr>
+              <a:t>The telling number</a:t>
+            </a:r>
+            <a:endParaRPr lang="en-US" sz="1300" dirty="0"/>
+          </a:p>
+        </p:txBody>
+      </p:sp>
+      <p:sp>
+        <p:nvSpPr>
+          <p:cNvPr id="8" name="Text 6"/>
+          <p:cNvSpPr/>
+          <p:nvPr/>
+        </p:nvSpPr>
+        <p:spPr>
+          <a:xfrm>
+            <a:off x="914400" y="4023360"/>
+            <a:ext cx="4754880" cy="822960"/>
+          </a:xfrm>
+          <a:prstGeom prst="rect">
+            <a:avLst/>
+          </a:prstGeom>
+          <a:noFill/>
+          <a:ln/>
+        </p:spPr>
+        <p:txBody>
+          <a:bodyPr wrap="square" rtlCol="0" anchor="ctr"/>
+          <a:lstStyle/>
+          <a:p>
+            <a:pPr indent="0" marL="0">
+              <a:buNone/>
+            </a:pPr>
+            <a:r>
+              <a:rPr lang="en-US" sz="3000" b="1" dirty="0">
+                <a:solidFill>
+                  <a:srgbClr val="00A896"/>
                 </a:solidFill>
                 <a:latin typeface="Georgia" pitchFamily="34" charset="0"/>
                 <a:ea typeface="Georgia" pitchFamily="34" charset="-122"/>
                 <a:cs typeface="Georgia" pitchFamily="34" charset="-120"/>
               </a:rPr>
-              <a:t>2 · calculator</a:t>
-            </a:r>
-            <a:endParaRPr lang="en-US" sz="1700" dirty="0"/>
+              <a:t>Keyword recall 0.74</a:t>
+            </a:r>
+            <a:endParaRPr lang="en-US" sz="3000" dirty="0"/>
           </a:p>
         </p:txBody>
       </p:sp>
@@ -2402,8 +2491,8 @@
         </p:nvSpPr>
         <p:spPr>
           <a:xfrm>
-            <a:off x="3931920" y="3657600"/>
-            <a:ext cx="7315200" cy="822960"/>
+            <a:off x="914400" y="4937760"/>
+            <a:ext cx="4754880" cy="914400"/>
           </a:xfrm>
           <a:prstGeom prst="rect">
             <a:avLst/>
@@ -2419,7 +2508,7 @@
               <a:buNone/>
             </a:pPr>
             <a:r>
-              <a:rPr lang="en-US" sz="1450" dirty="0">
+              <a:rPr lang="en-US" sz="1350" dirty="0">
                 <a:solidFill>
                   <a:srgbClr val="16203F"/>
                 </a:solidFill>
@@ -2427,9 +2516,9 @@
                 <a:ea typeface="Calibri" pitchFamily="34" charset="-122"/>
                 <a:cs typeface="Calibri" pitchFamily="34" charset="-120"/>
               </a:rPr>
-              <a:t>(120000 − 20000) / 8 = 12500 — exact, not estimated.</a:t>
-            </a:r>
-            <a:endParaRPr lang="en-US" sz="1450" dirty="0"/>
+              <a:t>The agent's answers contain the right content — they are just fuller than the references.</a:t>
+            </a:r>
+            <a:endParaRPr lang="en-US" sz="1350" dirty="0"/>
           </a:p>
         </p:txBody>
       </p:sp>
@@ -2441,14 +2530,14 @@
         </p:nvSpPr>
         <p:spPr>
           <a:xfrm>
-            <a:off x="640080" y="4800600"/>
-            <a:ext cx="10881360" cy="1097280"/>
+            <a:off x="6217920" y="3474720"/>
+            <a:ext cx="5303520" cy="2468880"/>
           </a:xfrm>
           <a:prstGeom prst="rect">
             <a:avLst/>
           </a:prstGeom>
           <a:solidFill>
-            <a:srgbClr val="1E2761"/>
+            <a:srgbClr val="FFFFFF"/>
           </a:solidFill>
           <a:ln w="12700">
             <a:solidFill>
@@ -2473,8 +2562,8 @@
         </p:nvSpPr>
         <p:spPr>
           <a:xfrm>
-            <a:off x="914400" y="4937760"/>
-            <a:ext cx="3017520" cy="822960"/>
+            <a:off x="6492240" y="3657600"/>
+            <a:ext cx="4754880" cy="365760"/>
           </a:xfrm>
           <a:prstGeom prst="rect">
             <a:avLst/>
@@ -2490,30 +2579,69 @@
               <a:buNone/>
             </a:pPr>
             <a:r>
-              <a:rPr lang="en-US" sz="1700" b="1" dirty="0">
+              <a:rPr lang="en-US" sz="1300" dirty="0">
                 <a:solidFill>
-                  <a:srgbClr val="00A896"/>
+                  <a:srgbClr val="5A6275"/>
+                </a:solidFill>
+                <a:latin typeface="Calibri" pitchFamily="34" charset="0"/>
+                <a:ea typeface="Calibri" pitchFamily="34" charset="-122"/>
+                <a:cs typeface="Calibri" pitchFamily="34" charset="-120"/>
+              </a:rPr>
+              <a:t>So we also judge meaning</a:t>
+            </a:r>
+            <a:endParaRPr lang="en-US" sz="1300" dirty="0"/>
+          </a:p>
+        </p:txBody>
+      </p:sp>
+      <p:sp>
+        <p:nvSpPr>
+          <p:cNvPr id="12" name="Text 10"/>
+          <p:cNvSpPr/>
+          <p:nvPr/>
+        </p:nvSpPr>
+        <p:spPr>
+          <a:xfrm>
+            <a:off x="6492240" y="4023360"/>
+            <a:ext cx="4754880" cy="640080"/>
+          </a:xfrm>
+          <a:prstGeom prst="rect">
+            <a:avLst/>
+          </a:prstGeom>
+          <a:noFill/>
+          <a:ln/>
+        </p:spPr>
+        <p:txBody>
+          <a:bodyPr wrap="square" rtlCol="0" anchor="ctr"/>
+          <a:lstStyle/>
+          <a:p>
+            <a:pPr indent="0" marL="0">
+              <a:buNone/>
+            </a:pPr>
+            <a:r>
+              <a:rPr lang="en-US" sz="2600" b="1" dirty="0">
+                <a:solidFill>
+                  <a:srgbClr val="1E2761"/>
                 </a:solidFill>
                 <a:latin typeface="Georgia" pitchFamily="34" charset="0"/>
                 <a:ea typeface="Georgia" pitchFamily="34" charset="-122"/>
                 <a:cs typeface="Georgia" pitchFamily="34" charset="-120"/>
               </a:rPr>
-              <a:t>3 · answer</a:t>
-            </a:r>
-            <a:endParaRPr lang="en-US" sz="1700" dirty="0"/>
-          </a:p>
-        </p:txBody>
-      </p:sp>
-      <p:sp>
-        <p:nvSpPr>
-          <p:cNvPr id="12" name="Text 10"/>
-          <p:cNvSpPr/>
-          <p:nvPr/>
-        </p:nvSpPr>
-        <p:spPr>
-          <a:xfrm>
-            <a:off x="3931920" y="4937760"/>
-            <a:ext cx="7315200" cy="822960"/>
+              <a:t>LLM-as-judge</a:t>
+            </a:r>
+            <a:endParaRPr lang="en-US" sz="2600" dirty="0"/>
+          </a:p>
+        </p:txBody>
+      </p:sp>
+      <p:sp>
+        <p:nvSpPr>
+          <p:cNvPr id="13" name="Text 11"/>
+          <p:cNvSpPr/>
+          <p:nvPr/>
+        </p:nvSpPr>
+        <p:spPr>
+          <a:xfrm>
+            <a:off x="6492240" y="4754880"/>
+            <a:ext cx="4754880" cy="1097280"/>
           </a:xfrm>
           <a:prstGeom prst="rect">
             <a:avLst/>
@@ -2529,17 +2657,17 @@
               <a:buNone/>
             </a:pPr>
             <a:r>
-              <a:rPr lang="en-US" sz="1450" dirty="0">
+              <a:rPr lang="en-US" sz="1350" dirty="0">
                 <a:solidFill>
-                  <a:srgbClr val="CADCFC"/>
+                  <a:srgbClr val="16203F"/>
                 </a:solidFill>
                 <a:latin typeface="Calibri" pitchFamily="34" charset="0"/>
                 <a:ea typeface="Calibri" pitchFamily="34" charset="-122"/>
                 <a:cs typeface="Calibri" pitchFamily="34" charset="-120"/>
               </a:rPr>
-              <a:t>“Annual depreciation is €12,500 (IAS 16, ¶50/53/62).” with the formula shown.</a:t>
-            </a:r>
-            <a:endParaRPr lang="en-US" sz="1450" dirty="0"/>
+              <a:t>Scores semantic equivalence rather than word overlap — the fairer measure for cited, explanatory answers.</a:t>
+            </a:r>
+            <a:endParaRPr lang="en-US" sz="1350" dirty="0"/>
           </a:p>
         </p:txBody>
       </p:sp>
@@ -2608,7 +2736,7 @@
                 <a:ea typeface="Georgia" pitchFamily="34" charset="-122"/>
                 <a:cs typeface="Georgia" pitchFamily="34" charset="-120"/>
               </a:rPr>
-              <a:t>Challenges we solved</a:t>
+              <a:t>Demo: tool chaining in one answer</a:t>
             </a:r>
             <a:endParaRPr lang="en-US" sz="3000" dirty="0"/>
           </a:p>
@@ -2616,14 +2744,53 @@
       </p:sp>
       <p:sp>
         <p:nvSpPr>
-          <p:cNvPr id="3" name="Shape 1"/>
-          <p:cNvSpPr/>
-          <p:nvPr/>
-        </p:nvSpPr>
-        <p:spPr>
-          <a:xfrm>
-            <a:off x="640080" y="1417320"/>
-            <a:ext cx="5303520" cy="2011680"/>
+          <p:cNvPr id="3" name="Text 1"/>
+          <p:cNvSpPr/>
+          <p:nvPr/>
+        </p:nvSpPr>
+        <p:spPr>
+          <a:xfrm>
+            <a:off x="640080" y="1325880"/>
+            <a:ext cx="10881360" cy="731520"/>
+          </a:xfrm>
+          <a:prstGeom prst="rect">
+            <a:avLst/>
+          </a:prstGeom>
+          <a:noFill/>
+          <a:ln/>
+        </p:spPr>
+        <p:txBody>
+          <a:bodyPr wrap="square" rtlCol="0" anchor="ctr"/>
+          <a:lstStyle/>
+          <a:p>
+            <a:pPr indent="0" marL="0">
+              <a:buNone/>
+            </a:pPr>
+            <a:r>
+              <a:rPr lang="en-US" sz="1600" i="1" dirty="0">
+                <a:solidFill>
+                  <a:srgbClr val="1E2761"/>
+                </a:solidFill>
+                <a:latin typeface="Calibri" pitchFamily="34" charset="0"/>
+                <a:ea typeface="Calibri" pitchFamily="34" charset="-122"/>
+                <a:cs typeface="Calibri" pitchFamily="34" charset="-120"/>
+              </a:rPr>
+              <a:t>"A machine costs €120,000, residual €20,000, useful life 8 years. Annual depreciation, and which standard?"</a:t>
+            </a:r>
+            <a:endParaRPr lang="en-US" sz="1600" dirty="0"/>
+          </a:p>
+        </p:txBody>
+      </p:sp>
+      <p:sp>
+        <p:nvSpPr>
+          <p:cNvPr id="4" name="Shape 2"/>
+          <p:cNvSpPr/>
+          <p:nvPr/>
+        </p:nvSpPr>
+        <p:spPr>
+          <a:xfrm>
+            <a:off x="640080" y="2240280"/>
+            <a:ext cx="10881360" cy="1097280"/>
           </a:xfrm>
           <a:prstGeom prst="rect">
             <a:avLst/>
@@ -2648,34 +2815,14 @@
       </p:sp>
       <p:sp>
         <p:nvSpPr>
-          <p:cNvPr id="4" name="Shape 2"/>
-          <p:cNvSpPr/>
-          <p:nvPr/>
-        </p:nvSpPr>
-        <p:spPr>
-          <a:xfrm>
-            <a:off x="640080" y="1417320"/>
-            <a:ext cx="109728" cy="2011680"/>
-          </a:xfrm>
-          <a:prstGeom prst="rect">
-            <a:avLst/>
-          </a:prstGeom>
-          <a:solidFill>
-            <a:srgbClr val="00A896"/>
-          </a:solidFill>
-          <a:ln/>
-        </p:spPr>
-      </p:sp>
-      <p:sp>
-        <p:nvSpPr>
           <p:cNvPr id="5" name="Text 3"/>
           <p:cNvSpPr/>
           <p:nvPr/>
         </p:nvSpPr>
         <p:spPr>
           <a:xfrm>
-            <a:off x="914400" y="1600200"/>
-            <a:ext cx="4846320" cy="457200"/>
+            <a:off x="914400" y="2377440"/>
+            <a:ext cx="3017520" cy="822960"/>
           </a:xfrm>
           <a:prstGeom prst="rect">
             <a:avLst/>
@@ -2691,7 +2838,7 @@
               <a:buNone/>
             </a:pPr>
             <a:r>
-              <a:rPr lang="en-US" sz="1800" b="1" dirty="0">
+              <a:rPr lang="en-US" sz="1700" b="1" dirty="0">
                 <a:solidFill>
                   <a:srgbClr val="1E2761"/>
                 </a:solidFill>
@@ -2699,9 +2846,9 @@
                 <a:ea typeface="Georgia" pitchFamily="34" charset="-122"/>
                 <a:cs typeface="Georgia" pitchFamily="34" charset="-120"/>
               </a:rPr>
-              <a:t>Models age fast</a:t>
-            </a:r>
-            <a:endParaRPr lang="en-US" sz="1800" dirty="0"/>
+              <a:t>1 · search_standards</a:t>
+            </a:r>
+            <a:endParaRPr lang="en-US" sz="1700" dirty="0"/>
           </a:p>
         </p:txBody>
       </p:sp>
@@ -2713,8 +2860,8 @@
         </p:nvSpPr>
         <p:spPr>
           <a:xfrm>
-            <a:off x="914400" y="2148840"/>
-            <a:ext cx="4846320" cy="1188720"/>
+            <a:off x="3931920" y="2377440"/>
+            <a:ext cx="7315200" cy="822960"/>
           </a:xfrm>
           <a:prstGeom prst="rect">
             <a:avLst/>
@@ -2730,7 +2877,7 @@
               <a:buNone/>
             </a:pPr>
             <a:r>
-              <a:rPr lang="en-US" sz="1400" dirty="0">
+              <a:rPr lang="en-US" sz="1450" dirty="0">
                 <a:solidFill>
                   <a:srgbClr val="16203F"/>
                 </a:solidFill>
@@ -2738,9 +2885,9 @@
                 <a:ea typeface="Calibri" pitchFamily="34" charset="-122"/>
                 <a:cs typeface="Calibri" pitchFamily="34" charset="-120"/>
               </a:rPr>
-              <a:t>Three Gemini models we depended on were retired or zero-quota within months — pinned versions and documented the stack.</a:t>
-            </a:r>
-            <a:endParaRPr lang="en-US" sz="1400" dirty="0"/>
+              <a:t>Finds IAS 16 — depreciable amount allocated over useful life (¶50, 53, 62).</a:t>
+            </a:r>
+            <a:endParaRPr lang="en-US" sz="1450" dirty="0"/>
           </a:p>
         </p:txBody>
       </p:sp>
@@ -2752,8 +2899,8 @@
         </p:nvSpPr>
         <p:spPr>
           <a:xfrm>
-            <a:off x="6172200" y="1417320"/>
-            <a:ext cx="5303520" cy="2011680"/>
+            <a:off x="640080" y="3520440"/>
+            <a:ext cx="10881360" cy="1097280"/>
           </a:xfrm>
           <a:prstGeom prst="rect">
             <a:avLst/>
@@ -2778,34 +2925,14 @@
       </p:sp>
       <p:sp>
         <p:nvSpPr>
-          <p:cNvPr id="8" name="Shape 6"/>
-          <p:cNvSpPr/>
-          <p:nvPr/>
-        </p:nvSpPr>
-        <p:spPr>
-          <a:xfrm>
-            <a:off x="6172200" y="1417320"/>
-            <a:ext cx="109728" cy="2011680"/>
-          </a:xfrm>
-          <a:prstGeom prst="rect">
-            <a:avLst/>
-          </a:prstGeom>
-          <a:solidFill>
-            <a:srgbClr val="00A896"/>
-          </a:solidFill>
-          <a:ln/>
-        </p:spPr>
-      </p:sp>
-      <p:sp>
-        <p:nvSpPr>
-          <p:cNvPr id="9" name="Text 7"/>
-          <p:cNvSpPr/>
-          <p:nvPr/>
-        </p:nvSpPr>
-        <p:spPr>
-          <a:xfrm>
-            <a:off x="6446520" y="1600200"/>
-            <a:ext cx="4846320" cy="457200"/>
+          <p:cNvPr id="8" name="Text 6"/>
+          <p:cNvSpPr/>
+          <p:nvPr/>
+        </p:nvSpPr>
+        <p:spPr>
+          <a:xfrm>
+            <a:off x="914400" y="3657600"/>
+            <a:ext cx="3017520" cy="822960"/>
           </a:xfrm>
           <a:prstGeom prst="rect">
             <a:avLst/>
@@ -2821,7 +2948,7 @@
               <a:buNone/>
             </a:pPr>
             <a:r>
-              <a:rPr lang="en-US" sz="1800" b="1" dirty="0">
+              <a:rPr lang="en-US" sz="1700" b="1" dirty="0">
                 <a:solidFill>
                   <a:srgbClr val="1E2761"/>
                 </a:solidFill>
@@ -2829,22 +2956,22 @@
                 <a:ea typeface="Georgia" pitchFamily="34" charset="-122"/>
                 <a:cs typeface="Georgia" pitchFamily="34" charset="-120"/>
               </a:rPr>
-              <a:t>Silent chunking bug</a:t>
-            </a:r>
-            <a:endParaRPr lang="en-US" sz="1800" dirty="0"/>
-          </a:p>
-        </p:txBody>
-      </p:sp>
-      <p:sp>
-        <p:nvSpPr>
-          <p:cNvPr id="10" name="Text 8"/>
-          <p:cNvSpPr/>
-          <p:nvPr/>
-        </p:nvSpPr>
-        <p:spPr>
-          <a:xfrm>
-            <a:off x="6446520" y="2148840"/>
-            <a:ext cx="4846320" cy="1188720"/>
+              <a:t>2 · calculator</a:t>
+            </a:r>
+            <a:endParaRPr lang="en-US" sz="1700" dirty="0"/>
+          </a:p>
+        </p:txBody>
+      </p:sp>
+      <p:sp>
+        <p:nvSpPr>
+          <p:cNvPr id="9" name="Text 7"/>
+          <p:cNvSpPr/>
+          <p:nvPr/>
+        </p:nvSpPr>
+        <p:spPr>
+          <a:xfrm>
+            <a:off x="3931920" y="3657600"/>
+            <a:ext cx="7315200" cy="822960"/>
           </a:xfrm>
           <a:prstGeom prst="rect">
             <a:avLst/>
@@ -2860,7 +2987,7 @@
               <a:buNone/>
             </a:pPr>
             <a:r>
-              <a:rPr lang="en-US" sz="1400" dirty="0">
+              <a:rPr lang="en-US" sz="1450" dirty="0">
                 <a:solidFill>
                   <a:srgbClr val="16203F"/>
                 </a:solidFill>
@@ -2868,21 +2995,202 @@
                 <a:ea typeface="Calibri" pitchFamily="34" charset="-122"/>
                 <a:cs typeface="Calibri" pitchFamily="34" charset="-120"/>
               </a:rPr>
-              <a:t>The template indexed 5 giant blobs; fixed to 167 section-aligned chunks with citations.</a:t>
-            </a:r>
-            <a:endParaRPr lang="en-US" sz="1400" dirty="0"/>
-          </a:p>
-        </p:txBody>
-      </p:sp>
-      <p:sp>
-        <p:nvSpPr>
-          <p:cNvPr id="11" name="Shape 9"/>
-          <p:cNvSpPr/>
-          <p:nvPr/>
-        </p:nvSpPr>
-        <p:spPr>
-          <a:xfrm>
-            <a:off x="640080" y="3657600"/>
+              <a:t>(120000 − 20000) / 8 = 12500 — exact, not estimated.</a:t>
+            </a:r>
+            <a:endParaRPr lang="en-US" sz="1450" dirty="0"/>
+          </a:p>
+        </p:txBody>
+      </p:sp>
+      <p:sp>
+        <p:nvSpPr>
+          <p:cNvPr id="10" name="Shape 8"/>
+          <p:cNvSpPr/>
+          <p:nvPr/>
+        </p:nvSpPr>
+        <p:spPr>
+          <a:xfrm>
+            <a:off x="640080" y="4800600"/>
+            <a:ext cx="10881360" cy="1097280"/>
+          </a:xfrm>
+          <a:prstGeom prst="rect">
+            <a:avLst/>
+          </a:prstGeom>
+          <a:solidFill>
+            <a:srgbClr val="1E2761"/>
+          </a:solidFill>
+          <a:ln w="12700">
+            <a:solidFill>
+              <a:srgbClr val="CADCFC"/>
+            </a:solidFill>
+            <a:prstDash val="solid"/>
+          </a:ln>
+          <a:effectLst>
+            <a:outerShdw sx="100000" sy="100000" kx="0" ky="0" algn="bl" rotWithShape="0" blurRad="76200" dist="25400" dir="8100000">
+              <a:srgbClr val="000000">
+                <a:alpha val="10000"/>
+              </a:srgbClr>
+            </a:outerShdw>
+          </a:effectLst>
+        </p:spPr>
+      </p:sp>
+      <p:sp>
+        <p:nvSpPr>
+          <p:cNvPr id="11" name="Text 9"/>
+          <p:cNvSpPr/>
+          <p:nvPr/>
+        </p:nvSpPr>
+        <p:spPr>
+          <a:xfrm>
+            <a:off x="914400" y="4937760"/>
+            <a:ext cx="3017520" cy="822960"/>
+          </a:xfrm>
+          <a:prstGeom prst="rect">
+            <a:avLst/>
+          </a:prstGeom>
+          <a:noFill/>
+          <a:ln/>
+        </p:spPr>
+        <p:txBody>
+          <a:bodyPr wrap="square" rtlCol="0" anchor="ctr"/>
+          <a:lstStyle/>
+          <a:p>
+            <a:pPr indent="0" marL="0">
+              <a:buNone/>
+            </a:pPr>
+            <a:r>
+              <a:rPr lang="en-US" sz="1700" b="1" dirty="0">
+                <a:solidFill>
+                  <a:srgbClr val="00A896"/>
+                </a:solidFill>
+                <a:latin typeface="Georgia" pitchFamily="34" charset="0"/>
+                <a:ea typeface="Georgia" pitchFamily="34" charset="-122"/>
+                <a:cs typeface="Georgia" pitchFamily="34" charset="-120"/>
+              </a:rPr>
+              <a:t>3 · answer</a:t>
+            </a:r>
+            <a:endParaRPr lang="en-US" sz="1700" dirty="0"/>
+          </a:p>
+        </p:txBody>
+      </p:sp>
+      <p:sp>
+        <p:nvSpPr>
+          <p:cNvPr id="12" name="Text 10"/>
+          <p:cNvSpPr/>
+          <p:nvPr/>
+        </p:nvSpPr>
+        <p:spPr>
+          <a:xfrm>
+            <a:off x="3931920" y="4937760"/>
+            <a:ext cx="7315200" cy="822960"/>
+          </a:xfrm>
+          <a:prstGeom prst="rect">
+            <a:avLst/>
+          </a:prstGeom>
+          <a:noFill/>
+          <a:ln/>
+        </p:spPr>
+        <p:txBody>
+          <a:bodyPr wrap="square" rtlCol="0" anchor="ctr"/>
+          <a:lstStyle/>
+          <a:p>
+            <a:pPr indent="0" marL="0">
+              <a:buNone/>
+            </a:pPr>
+            <a:r>
+              <a:rPr lang="en-US" sz="1450" dirty="0">
+                <a:solidFill>
+                  <a:srgbClr val="CADCFC"/>
+                </a:solidFill>
+                <a:latin typeface="Calibri" pitchFamily="34" charset="0"/>
+                <a:ea typeface="Calibri" pitchFamily="34" charset="-122"/>
+                <a:cs typeface="Calibri" pitchFamily="34" charset="-120"/>
+              </a:rPr>
+              <a:t>“Annual depreciation is €12,500 (IAS 16, ¶50/53/62).” with the formula shown.</a:t>
+            </a:r>
+            <a:endParaRPr lang="en-US" sz="1450" dirty="0"/>
+          </a:p>
+        </p:txBody>
+      </p:sp>
+    </p:spTree>
+  </p:cSld>
+  <p:clrMapOvr>
+    <a:masterClrMapping/>
+  </p:clrMapOvr>
+</p:sld>
+</file>
+
+<file path=ppt/slides/slide12.xml><?xml version="1.0" encoding="utf-8"?>
+<p:sld xmlns:a="http://schemas.openxmlformats.org/drawingml/2006/main" xmlns:r="http://schemas.openxmlformats.org/officeDocument/2006/relationships" xmlns:p="http://schemas.openxmlformats.org/presentationml/2006/main">
+  <p:cSld name="Slide 12">
+    <p:bg>
+      <p:bgPr>
+        <a:solidFill>
+          <a:srgbClr val="FFFFFF"/>
+        </a:solidFill>
+      </p:bgPr>
+    </p:bg>
+    <p:spTree>
+      <p:nvGrpSpPr>
+        <p:cNvPr id="1" name=""/>
+        <p:cNvGrpSpPr/>
+        <p:nvPr/>
+      </p:nvGrpSpPr>
+      <p:grpSpPr>
+        <a:xfrm>
+          <a:off x="0" y="0"/>
+          <a:ext cx="0" cy="0"/>
+          <a:chOff x="0" y="0"/>
+          <a:chExt cx="0" cy="0"/>
+        </a:xfrm>
+      </p:grpSpPr>
+      <p:sp>
+        <p:nvSpPr>
+          <p:cNvPr id="2" name="Text 0"/>
+          <p:cNvSpPr/>
+          <p:nvPr/>
+        </p:nvSpPr>
+        <p:spPr>
+          <a:xfrm>
+            <a:off x="640080" y="411480"/>
+            <a:ext cx="10972800" cy="731520"/>
+          </a:xfrm>
+          <a:prstGeom prst="rect">
+            <a:avLst/>
+          </a:prstGeom>
+          <a:noFill/>
+          <a:ln/>
+        </p:spPr>
+        <p:txBody>
+          <a:bodyPr wrap="square" rtlCol="0" anchor="ctr"/>
+          <a:lstStyle/>
+          <a:p>
+            <a:pPr indent="0" marL="0">
+              <a:buNone/>
+            </a:pPr>
+            <a:r>
+              <a:rPr lang="en-US" sz="3000" b="1" dirty="0">
+                <a:solidFill>
+                  <a:srgbClr val="1E2761"/>
+                </a:solidFill>
+                <a:latin typeface="Georgia" pitchFamily="34" charset="0"/>
+                <a:ea typeface="Georgia" pitchFamily="34" charset="-122"/>
+                <a:cs typeface="Georgia" pitchFamily="34" charset="-120"/>
+              </a:rPr>
+              <a:t>Challenges we solved</a:t>
+            </a:r>
+            <a:endParaRPr lang="en-US" sz="3000" dirty="0"/>
+          </a:p>
+        </p:txBody>
+      </p:sp>
+      <p:sp>
+        <p:nvSpPr>
+          <p:cNvPr id="3" name="Shape 1"/>
+          <p:cNvSpPr/>
+          <p:nvPr/>
+        </p:nvSpPr>
+        <p:spPr>
+          <a:xfrm>
+            <a:off x="640080" y="1417320"/>
             <a:ext cx="5303520" cy="2011680"/>
           </a:xfrm>
           <a:prstGeom prst="rect">
@@ -2908,13 +3216,13 @@
       </p:sp>
       <p:sp>
         <p:nvSpPr>
-          <p:cNvPr id="12" name="Shape 10"/>
-          <p:cNvSpPr/>
-          <p:nvPr/>
-        </p:nvSpPr>
-        <p:spPr>
-          <a:xfrm>
-            <a:off x="640080" y="3657600"/>
+          <p:cNvPr id="4" name="Shape 2"/>
+          <p:cNvSpPr/>
+          <p:nvPr/>
+        </p:nvSpPr>
+        <p:spPr>
+          <a:xfrm>
+            <a:off x="640080" y="1417320"/>
             <a:ext cx="109728" cy="2011680"/>
           </a:xfrm>
           <a:prstGeom prst="rect">
@@ -2928,13 +3236,13 @@
       </p:sp>
       <p:sp>
         <p:nvSpPr>
-          <p:cNvPr id="13" name="Text 11"/>
-          <p:cNvSpPr/>
-          <p:nvPr/>
-        </p:nvSpPr>
-        <p:spPr>
-          <a:xfrm>
-            <a:off x="914400" y="3840480"/>
+          <p:cNvPr id="5" name="Text 3"/>
+          <p:cNvSpPr/>
+          <p:nvPr/>
+        </p:nvSpPr>
+        <p:spPr>
+          <a:xfrm>
+            <a:off x="914400" y="1600200"/>
             <a:ext cx="4846320" cy="457200"/>
           </a:xfrm>
           <a:prstGeom prst="rect">
@@ -2959,7 +3267,7 @@
                 <a:ea typeface="Georgia" pitchFamily="34" charset="-122"/>
                 <a:cs typeface="Georgia" pitchFamily="34" charset="-120"/>
               </a:rPr>
-              <a:t>Free-tier quotas</a:t>
+              <a:t>Models age fast</a:t>
             </a:r>
             <a:endParaRPr lang="en-US" sz="1800" dirty="0"/>
           </a:p>
@@ -2967,13 +3275,13 @@
       </p:sp>
       <p:sp>
         <p:nvSpPr>
-          <p:cNvPr id="14" name="Text 12"/>
-          <p:cNvSpPr/>
-          <p:nvPr/>
-        </p:nvSpPr>
-        <p:spPr>
-          <a:xfrm>
-            <a:off x="914400" y="4389120"/>
+          <p:cNvPr id="6" name="Text 4"/>
+          <p:cNvSpPr/>
+          <p:nvPr/>
+        </p:nvSpPr>
+        <p:spPr>
+          <a:xfrm>
+            <a:off x="914400" y="2148840"/>
             <a:ext cx="4846320" cy="1188720"/>
           </a:xfrm>
           <a:prstGeom prst="rect">
@@ -2998,7 +3306,7 @@
                 <a:ea typeface="Calibri" pitchFamily="34" charset="-122"/>
                 <a:cs typeface="Calibri" pitchFamily="34" charset="-120"/>
               </a:rPr>
-              <a:t>Agents are multi-call per question; daily caps were the real limit. Made every run paced, retrying and resumable.</a:t>
+              <a:t>Three Gemini models we depended on were retired or zero-quota within months — pinned versions and documented the stack.</a:t>
             </a:r>
             <a:endParaRPr lang="en-US" sz="1400" dirty="0"/>
           </a:p>
@@ -3006,13 +3314,13 @@
       </p:sp>
       <p:sp>
         <p:nvSpPr>
-          <p:cNvPr id="15" name="Shape 13"/>
-          <p:cNvSpPr/>
-          <p:nvPr/>
-        </p:nvSpPr>
-        <p:spPr>
-          <a:xfrm>
-            <a:off x="6172200" y="3657600"/>
+          <p:cNvPr id="7" name="Shape 5"/>
+          <p:cNvSpPr/>
+          <p:nvPr/>
+        </p:nvSpPr>
+        <p:spPr>
+          <a:xfrm>
+            <a:off x="6172200" y="1417320"/>
             <a:ext cx="5303520" cy="2011680"/>
           </a:xfrm>
           <a:prstGeom prst="rect">
@@ -3038,6 +3346,266 @@
       </p:sp>
       <p:sp>
         <p:nvSpPr>
+          <p:cNvPr id="8" name="Shape 6"/>
+          <p:cNvSpPr/>
+          <p:nvPr/>
+        </p:nvSpPr>
+        <p:spPr>
+          <a:xfrm>
+            <a:off x="6172200" y="1417320"/>
+            <a:ext cx="109728" cy="2011680"/>
+          </a:xfrm>
+          <a:prstGeom prst="rect">
+            <a:avLst/>
+          </a:prstGeom>
+          <a:solidFill>
+            <a:srgbClr val="00A896"/>
+          </a:solidFill>
+          <a:ln/>
+        </p:spPr>
+      </p:sp>
+      <p:sp>
+        <p:nvSpPr>
+          <p:cNvPr id="9" name="Text 7"/>
+          <p:cNvSpPr/>
+          <p:nvPr/>
+        </p:nvSpPr>
+        <p:spPr>
+          <a:xfrm>
+            <a:off x="6446520" y="1600200"/>
+            <a:ext cx="4846320" cy="457200"/>
+          </a:xfrm>
+          <a:prstGeom prst="rect">
+            <a:avLst/>
+          </a:prstGeom>
+          <a:noFill/>
+          <a:ln/>
+        </p:spPr>
+        <p:txBody>
+          <a:bodyPr wrap="square" rtlCol="0" anchor="ctr"/>
+          <a:lstStyle/>
+          <a:p>
+            <a:pPr indent="0" marL="0">
+              <a:buNone/>
+            </a:pPr>
+            <a:r>
+              <a:rPr lang="en-US" sz="1800" b="1" dirty="0">
+                <a:solidFill>
+                  <a:srgbClr val="1E2761"/>
+                </a:solidFill>
+                <a:latin typeface="Georgia" pitchFamily="34" charset="0"/>
+                <a:ea typeface="Georgia" pitchFamily="34" charset="-122"/>
+                <a:cs typeface="Georgia" pitchFamily="34" charset="-120"/>
+              </a:rPr>
+              <a:t>Silent chunking bug</a:t>
+            </a:r>
+            <a:endParaRPr lang="en-US" sz="1800" dirty="0"/>
+          </a:p>
+        </p:txBody>
+      </p:sp>
+      <p:sp>
+        <p:nvSpPr>
+          <p:cNvPr id="10" name="Text 8"/>
+          <p:cNvSpPr/>
+          <p:nvPr/>
+        </p:nvSpPr>
+        <p:spPr>
+          <a:xfrm>
+            <a:off x="6446520" y="2148840"/>
+            <a:ext cx="4846320" cy="1188720"/>
+          </a:xfrm>
+          <a:prstGeom prst="rect">
+            <a:avLst/>
+          </a:prstGeom>
+          <a:noFill/>
+          <a:ln/>
+        </p:spPr>
+        <p:txBody>
+          <a:bodyPr wrap="square" rtlCol="0" anchor="ctr"/>
+          <a:lstStyle/>
+          <a:p>
+            <a:pPr indent="0" marL="0">
+              <a:buNone/>
+            </a:pPr>
+            <a:r>
+              <a:rPr lang="en-US" sz="1400" dirty="0">
+                <a:solidFill>
+                  <a:srgbClr val="16203F"/>
+                </a:solidFill>
+                <a:latin typeface="Calibri" pitchFamily="34" charset="0"/>
+                <a:ea typeface="Calibri" pitchFamily="34" charset="-122"/>
+                <a:cs typeface="Calibri" pitchFamily="34" charset="-120"/>
+              </a:rPr>
+              <a:t>The template indexed 5 giant blobs; fixed to 167 section-aligned chunks with citations.</a:t>
+            </a:r>
+            <a:endParaRPr lang="en-US" sz="1400" dirty="0"/>
+          </a:p>
+        </p:txBody>
+      </p:sp>
+      <p:sp>
+        <p:nvSpPr>
+          <p:cNvPr id="11" name="Shape 9"/>
+          <p:cNvSpPr/>
+          <p:nvPr/>
+        </p:nvSpPr>
+        <p:spPr>
+          <a:xfrm>
+            <a:off x="640080" y="3657600"/>
+            <a:ext cx="5303520" cy="2011680"/>
+          </a:xfrm>
+          <a:prstGeom prst="rect">
+            <a:avLst/>
+          </a:prstGeom>
+          <a:solidFill>
+            <a:srgbClr val="F4F7FB"/>
+          </a:solidFill>
+          <a:ln w="12700">
+            <a:solidFill>
+              <a:srgbClr val="CADCFC"/>
+            </a:solidFill>
+            <a:prstDash val="solid"/>
+          </a:ln>
+          <a:effectLst>
+            <a:outerShdw sx="100000" sy="100000" kx="0" ky="0" algn="bl" rotWithShape="0" blurRad="76200" dist="25400" dir="8100000">
+              <a:srgbClr val="000000">
+                <a:alpha val="10000"/>
+              </a:srgbClr>
+            </a:outerShdw>
+          </a:effectLst>
+        </p:spPr>
+      </p:sp>
+      <p:sp>
+        <p:nvSpPr>
+          <p:cNvPr id="12" name="Shape 10"/>
+          <p:cNvSpPr/>
+          <p:nvPr/>
+        </p:nvSpPr>
+        <p:spPr>
+          <a:xfrm>
+            <a:off x="640080" y="3657600"/>
+            <a:ext cx="109728" cy="2011680"/>
+          </a:xfrm>
+          <a:prstGeom prst="rect">
+            <a:avLst/>
+          </a:prstGeom>
+          <a:solidFill>
+            <a:srgbClr val="00A896"/>
+          </a:solidFill>
+          <a:ln/>
+        </p:spPr>
+      </p:sp>
+      <p:sp>
+        <p:nvSpPr>
+          <p:cNvPr id="13" name="Text 11"/>
+          <p:cNvSpPr/>
+          <p:nvPr/>
+        </p:nvSpPr>
+        <p:spPr>
+          <a:xfrm>
+            <a:off x="914400" y="3840480"/>
+            <a:ext cx="4846320" cy="457200"/>
+          </a:xfrm>
+          <a:prstGeom prst="rect">
+            <a:avLst/>
+          </a:prstGeom>
+          <a:noFill/>
+          <a:ln/>
+        </p:spPr>
+        <p:txBody>
+          <a:bodyPr wrap="square" rtlCol="0" anchor="ctr"/>
+          <a:lstStyle/>
+          <a:p>
+            <a:pPr indent="0" marL="0">
+              <a:buNone/>
+            </a:pPr>
+            <a:r>
+              <a:rPr lang="en-US" sz="1800" b="1" dirty="0">
+                <a:solidFill>
+                  <a:srgbClr val="1E2761"/>
+                </a:solidFill>
+                <a:latin typeface="Georgia" pitchFamily="34" charset="0"/>
+                <a:ea typeface="Georgia" pitchFamily="34" charset="-122"/>
+                <a:cs typeface="Georgia" pitchFamily="34" charset="-120"/>
+              </a:rPr>
+              <a:t>Free-tier quotas</a:t>
+            </a:r>
+            <a:endParaRPr lang="en-US" sz="1800" dirty="0"/>
+          </a:p>
+        </p:txBody>
+      </p:sp>
+      <p:sp>
+        <p:nvSpPr>
+          <p:cNvPr id="14" name="Text 12"/>
+          <p:cNvSpPr/>
+          <p:nvPr/>
+        </p:nvSpPr>
+        <p:spPr>
+          <a:xfrm>
+            <a:off x="914400" y="4389120"/>
+            <a:ext cx="4846320" cy="1188720"/>
+          </a:xfrm>
+          <a:prstGeom prst="rect">
+            <a:avLst/>
+          </a:prstGeom>
+          <a:noFill/>
+          <a:ln/>
+        </p:spPr>
+        <p:txBody>
+          <a:bodyPr wrap="square" rtlCol="0" anchor="ctr"/>
+          <a:lstStyle/>
+          <a:p>
+            <a:pPr indent="0" marL="0">
+              <a:buNone/>
+            </a:pPr>
+            <a:r>
+              <a:rPr lang="en-US" sz="1400" dirty="0">
+                <a:solidFill>
+                  <a:srgbClr val="16203F"/>
+                </a:solidFill>
+                <a:latin typeface="Calibri" pitchFamily="34" charset="0"/>
+                <a:ea typeface="Calibri" pitchFamily="34" charset="-122"/>
+                <a:cs typeface="Calibri" pitchFamily="34" charset="-120"/>
+              </a:rPr>
+              <a:t>Agents are multi-call per question; daily caps were the real limit. Made every run paced, retrying and resumable.</a:t>
+            </a:r>
+            <a:endParaRPr lang="en-US" sz="1400" dirty="0"/>
+          </a:p>
+        </p:txBody>
+      </p:sp>
+      <p:sp>
+        <p:nvSpPr>
+          <p:cNvPr id="15" name="Shape 13"/>
+          <p:cNvSpPr/>
+          <p:nvPr/>
+        </p:nvSpPr>
+        <p:spPr>
+          <a:xfrm>
+            <a:off x="6172200" y="3657600"/>
+            <a:ext cx="5303520" cy="2011680"/>
+          </a:xfrm>
+          <a:prstGeom prst="rect">
+            <a:avLst/>
+          </a:prstGeom>
+          <a:solidFill>
+            <a:srgbClr val="F4F7FB"/>
+          </a:solidFill>
+          <a:ln w="12700">
+            <a:solidFill>
+              <a:srgbClr val="CADCFC"/>
+            </a:solidFill>
+            <a:prstDash val="solid"/>
+          </a:ln>
+          <a:effectLst>
+            <a:outerShdw sx="100000" sy="100000" kx="0" ky="0" algn="bl" rotWithShape="0" blurRad="76200" dist="25400" dir="8100000">
+              <a:srgbClr val="000000">
+                <a:alpha val="10000"/>
+              </a:srgbClr>
+            </a:outerShdw>
+          </a:effectLst>
+        </p:spPr>
+      </p:sp>
+      <p:sp>
+        <p:nvSpPr>
           <p:cNvPr id="16" name="Shape 14"/>
           <p:cNvSpPr/>
           <p:nvPr/>
@@ -3142,9 +3710,9 @@
 </p:sld>
 </file>
 
-<file path=ppt/slides/slide12.xml><?xml version="1.0" encoding="utf-8"?>
+<file path=ppt/slides/slide13.xml><?xml version="1.0" encoding="utf-8"?>
 <p:sld xmlns:a="http://schemas.openxmlformats.org/drawingml/2006/main" xmlns:r="http://schemas.openxmlformats.org/officeDocument/2006/relationships" xmlns:p="http://schemas.openxmlformats.org/presentationml/2006/main">
-  <p:cSld name="Slide 12">
+  <p:cSld name="Slide 13">
     <p:bg>
       <p:bgPr>
         <a:solidFill>
@@ -6245,54 +6813,1441 @@
                 <a:ea typeface="Georgia" pitchFamily="34" charset="-122"/>
                 <a:cs typeface="Georgia" pitchFamily="34" charset="-120"/>
               </a:rPr>
-              <a:t>Evaluation methodology</a:t>
+              <a:t>Design decisions &amp; alternatives rejected</a:t>
             </a:r>
             <a:endParaRPr lang="en-US" sz="3000" dirty="0"/>
           </a:p>
         </p:txBody>
       </p:sp>
-      <p:sp>
-        <p:nvSpPr>
-          <p:cNvPr id="3" name="Shape 1"/>
-          <p:cNvSpPr/>
-          <p:nvPr/>
-        </p:nvSpPr>
-        <p:spPr>
-          <a:xfrm>
-            <a:off x="640080" y="1371600"/>
-            <a:ext cx="10881360" cy="2011680"/>
-          </a:xfrm>
-          <a:prstGeom prst="rect">
-            <a:avLst/>
-          </a:prstGeom>
-          <a:solidFill>
-            <a:srgbClr val="F4F7FB"/>
-          </a:solidFill>
-          <a:ln w="12700">
-            <a:solidFill>
-              <a:srgbClr val="CADCFC"/>
-            </a:solidFill>
-            <a:prstDash val="solid"/>
-          </a:ln>
-          <a:effectLst>
-            <a:outerShdw sx="100000" sy="100000" kx="0" ky="0" algn="bl" rotWithShape="0" blurRad="76200" dist="25400" dir="8100000">
-              <a:srgbClr val="000000">
-                <a:alpha val="10000"/>
-              </a:srgbClr>
-            </a:outerShdw>
-          </a:effectLst>
-        </p:spPr>
-      </p:sp>
-      <p:sp>
-        <p:nvSpPr>
-          <p:cNvPr id="4" name="Text 2"/>
-          <p:cNvSpPr/>
-          <p:nvPr/>
-        </p:nvSpPr>
-        <p:spPr>
-          <a:xfrm>
-            <a:off x="914400" y="1554480"/>
-            <a:ext cx="10332720" cy="457200"/>
+      <p:graphicFrame>
+        <p:nvGraphicFramePr>
+          <p:cNvPr id="8" name="Table 0"/>
+          <p:cNvGraphicFramePr>
+            <a:graphicFrameLocks noGrp="1"/>
+          </p:cNvGraphicFramePr>
+          <p:nvPr>
+            <p:extLst>
+              <p:ext uri="{D42A27DB-BD31-4B8C-83A1-F6EECF244321}">
+                <p14:modId xmlns:p14="http://schemas.microsoft.com/office/powerpoint/2010/main" val="1579011935"/>
+              </p:ext>
+            </p:extLst>
+          </p:nvPr>
+        </p:nvGraphicFramePr>
+        <p:xfrm>
+          <a:off x="640080" y="1371600"/>
+          <a:ext cx="10881360" cy="4206240"/>
+        </p:xfrm>
+        <a:graphic>
+          <a:graphicData uri="http://schemas.openxmlformats.org/drawingml/2006/table">
+            <a:tbl>
+              <a:tblPr/>
+              <a:tblGrid>
+                <a:gridCol w="2194560"/>
+                <a:gridCol w="3017520"/>
+                <a:gridCol w="5669280"/>
+              </a:tblGrid>
+              <a:tr h="457200">
+                <a:tc>
+                  <a:txBody>
+                    <a:bodyPr/>
+                    <a:lstStyle/>
+                    <a:p>
+                      <a:pPr indent="0" marL="0">
+                        <a:buNone/>
+                      </a:pPr>
+                      <a:r>
+                        <a:rPr lang="en-US" sz="1300" b="1" dirty="0">
+                          <a:solidFill>
+                            <a:srgbClr val="FFFFFF"/>
+                          </a:solidFill>
+                          <a:latin typeface="Calibri" pitchFamily="34" charset="0"/>
+                          <a:ea typeface="Calibri" pitchFamily="34" charset="-122"/>
+                          <a:cs typeface="Calibri" pitchFamily="34" charset="-120"/>
+                        </a:rPr>
+                        <a:t>Decision</a:t>
+                      </a:r>
+                      <a:endParaRPr lang="en-US" sz="1300" dirty="0">
+                        <a:latin typeface="Calibri" charset="0"/>
+                        <a:ea typeface="Calibri" charset="0"/>
+                        <a:cs typeface="Calibri" charset="0"/>
+                      </a:endParaRPr>
+                    </a:p>
+                  </a:txBody>
+                  <a:tcPr marL="91440" marR="91440" marT="45720" marB="45720" anchor="ctr">
+                    <a:lnL w="6350" cap="flat" cmpd="sng" algn="ctr">
+                      <a:solidFill>
+                        <a:srgbClr val="CADCFC"/>
+                      </a:solidFill>
+                      <a:prstDash val="solid"/>
+                      <a:round/>
+                      <a:headEnd type="none" w="med" len="med"/>
+                      <a:tailEnd type="none" w="med" len="med"/>
+                    </a:lnL>
+                    <a:lnR w="6350" cap="flat" cmpd="sng" algn="ctr">
+                      <a:solidFill>
+                        <a:srgbClr val="CADCFC"/>
+                      </a:solidFill>
+                      <a:prstDash val="solid"/>
+                      <a:round/>
+                      <a:headEnd type="none" w="med" len="med"/>
+                      <a:tailEnd type="none" w="med" len="med"/>
+                    </a:lnR>
+                    <a:lnT w="6350" cap="flat" cmpd="sng" algn="ctr">
+                      <a:solidFill>
+                        <a:srgbClr val="CADCFC"/>
+                      </a:solidFill>
+                      <a:prstDash val="solid"/>
+                      <a:round/>
+                      <a:headEnd type="none" w="med" len="med"/>
+                      <a:tailEnd type="none" w="med" len="med"/>
+                    </a:lnT>
+                    <a:lnB w="6350" cap="flat" cmpd="sng" algn="ctr">
+                      <a:solidFill>
+                        <a:srgbClr val="CADCFC"/>
+                      </a:solidFill>
+                      <a:prstDash val="solid"/>
+                      <a:round/>
+                      <a:headEnd type="none" w="med" len="med"/>
+                      <a:tailEnd type="none" w="med" len="med"/>
+                    </a:lnB>
+                    <a:solidFill>
+                      <a:srgbClr val="1E2761"/>
+                    </a:solidFill>
+                  </a:tcPr>
+                </a:tc>
+                <a:tc>
+                  <a:txBody>
+                    <a:bodyPr/>
+                    <a:lstStyle/>
+                    <a:p>
+                      <a:pPr indent="0" marL="0">
+                        <a:buNone/>
+                      </a:pPr>
+                      <a:r>
+                        <a:rPr lang="en-US" sz="1300" b="1" dirty="0">
+                          <a:solidFill>
+                            <a:srgbClr val="FFFFFF"/>
+                          </a:solidFill>
+                          <a:latin typeface="Calibri" pitchFamily="34" charset="0"/>
+                          <a:ea typeface="Calibri" pitchFamily="34" charset="-122"/>
+                          <a:cs typeface="Calibri" pitchFamily="34" charset="-120"/>
+                        </a:rPr>
+                        <a:t>We chose</a:t>
+                      </a:r>
+                      <a:endParaRPr lang="en-US" sz="1300" dirty="0">
+                        <a:latin typeface="Calibri" charset="0"/>
+                        <a:ea typeface="Calibri" charset="0"/>
+                        <a:cs typeface="Calibri" charset="0"/>
+                      </a:endParaRPr>
+                    </a:p>
+                  </a:txBody>
+                  <a:tcPr marL="91440" marR="91440" marT="45720" marB="45720" anchor="ctr">
+                    <a:lnL w="6350" cap="flat" cmpd="sng" algn="ctr">
+                      <a:solidFill>
+                        <a:srgbClr val="CADCFC"/>
+                      </a:solidFill>
+                      <a:prstDash val="solid"/>
+                      <a:round/>
+                      <a:headEnd type="none" w="med" len="med"/>
+                      <a:tailEnd type="none" w="med" len="med"/>
+                    </a:lnL>
+                    <a:lnR w="6350" cap="flat" cmpd="sng" algn="ctr">
+                      <a:solidFill>
+                        <a:srgbClr val="CADCFC"/>
+                      </a:solidFill>
+                      <a:prstDash val="solid"/>
+                      <a:round/>
+                      <a:headEnd type="none" w="med" len="med"/>
+                      <a:tailEnd type="none" w="med" len="med"/>
+                    </a:lnR>
+                    <a:lnT w="6350" cap="flat" cmpd="sng" algn="ctr">
+                      <a:solidFill>
+                        <a:srgbClr val="CADCFC"/>
+                      </a:solidFill>
+                      <a:prstDash val="solid"/>
+                      <a:round/>
+                      <a:headEnd type="none" w="med" len="med"/>
+                      <a:tailEnd type="none" w="med" len="med"/>
+                    </a:lnT>
+                    <a:lnB w="6350" cap="flat" cmpd="sng" algn="ctr">
+                      <a:solidFill>
+                        <a:srgbClr val="CADCFC"/>
+                      </a:solidFill>
+                      <a:prstDash val="solid"/>
+                      <a:round/>
+                      <a:headEnd type="none" w="med" len="med"/>
+                      <a:tailEnd type="none" w="med" len="med"/>
+                    </a:lnB>
+                    <a:solidFill>
+                      <a:srgbClr val="1E2761"/>
+                    </a:solidFill>
+                  </a:tcPr>
+                </a:tc>
+                <a:tc>
+                  <a:txBody>
+                    <a:bodyPr/>
+                    <a:lstStyle/>
+                    <a:p>
+                      <a:pPr indent="0" marL="0">
+                        <a:buNone/>
+                      </a:pPr>
+                      <a:r>
+                        <a:rPr lang="en-US" sz="1300" b="1" dirty="0">
+                          <a:solidFill>
+                            <a:srgbClr val="FFFFFF"/>
+                          </a:solidFill>
+                          <a:latin typeface="Calibri" pitchFamily="34" charset="0"/>
+                          <a:ea typeface="Calibri" pitchFamily="34" charset="-122"/>
+                          <a:cs typeface="Calibri" pitchFamily="34" charset="-120"/>
+                        </a:rPr>
+                        <a:t>Rejected — why</a:t>
+                      </a:r>
+                      <a:endParaRPr lang="en-US" sz="1300" dirty="0">
+                        <a:latin typeface="Calibri" charset="0"/>
+                        <a:ea typeface="Calibri" charset="0"/>
+                        <a:cs typeface="Calibri" charset="0"/>
+                      </a:endParaRPr>
+                    </a:p>
+                  </a:txBody>
+                  <a:tcPr marL="91440" marR="91440" marT="45720" marB="45720" anchor="ctr">
+                    <a:lnL w="6350" cap="flat" cmpd="sng" algn="ctr">
+                      <a:solidFill>
+                        <a:srgbClr val="CADCFC"/>
+                      </a:solidFill>
+                      <a:prstDash val="solid"/>
+                      <a:round/>
+                      <a:headEnd type="none" w="med" len="med"/>
+                      <a:tailEnd type="none" w="med" len="med"/>
+                    </a:lnL>
+                    <a:lnR w="6350" cap="flat" cmpd="sng" algn="ctr">
+                      <a:solidFill>
+                        <a:srgbClr val="CADCFC"/>
+                      </a:solidFill>
+                      <a:prstDash val="solid"/>
+                      <a:round/>
+                      <a:headEnd type="none" w="med" len="med"/>
+                      <a:tailEnd type="none" w="med" len="med"/>
+                    </a:lnR>
+                    <a:lnT w="6350" cap="flat" cmpd="sng" algn="ctr">
+                      <a:solidFill>
+                        <a:srgbClr val="CADCFC"/>
+                      </a:solidFill>
+                      <a:prstDash val="solid"/>
+                      <a:round/>
+                      <a:headEnd type="none" w="med" len="med"/>
+                      <a:tailEnd type="none" w="med" len="med"/>
+                    </a:lnT>
+                    <a:lnB w="6350" cap="flat" cmpd="sng" algn="ctr">
+                      <a:solidFill>
+                        <a:srgbClr val="CADCFC"/>
+                      </a:solidFill>
+                      <a:prstDash val="solid"/>
+                      <a:round/>
+                      <a:headEnd type="none" w="med" len="med"/>
+                      <a:tailEnd type="none" w="med" len="med"/>
+                    </a:lnB>
+                    <a:solidFill>
+                      <a:srgbClr val="1E2761"/>
+                    </a:solidFill>
+                  </a:tcPr>
+                </a:tc>
+              </a:tr>
+              <a:tr h="640080">
+                <a:tc>
+                  <a:txBody>
+                    <a:bodyPr/>
+                    <a:lstStyle/>
+                    <a:p>
+                      <a:pPr indent="0" marL="0">
+                        <a:buNone/>
+                      </a:pPr>
+                      <a:r>
+                        <a:rPr lang="en-US" sz="1300" dirty="0">
+                          <a:solidFill>
+                            <a:srgbClr val="16203F"/>
+                          </a:solidFill>
+                          <a:latin typeface="Calibri" pitchFamily="34" charset="0"/>
+                          <a:ea typeface="Calibri" pitchFamily="34" charset="-122"/>
+                          <a:cs typeface="Calibri" pitchFamily="34" charset="-120"/>
+                        </a:rPr>
+                        <a:t>Architecture</a:t>
+                      </a:r>
+                      <a:endParaRPr lang="en-US" sz="1300" dirty="0">
+                        <a:latin typeface="Calibri" charset="0"/>
+                        <a:ea typeface="Calibri" charset="0"/>
+                        <a:cs typeface="Calibri" charset="0"/>
+                      </a:endParaRPr>
+                    </a:p>
+                  </a:txBody>
+                  <a:tcPr marL="91440" marR="91440" marT="45720" marB="45720" anchor="ctr">
+                    <a:lnL w="6350" cap="flat" cmpd="sng" algn="ctr">
+                      <a:solidFill>
+                        <a:srgbClr val="CADCFC"/>
+                      </a:solidFill>
+                      <a:prstDash val="solid"/>
+                      <a:round/>
+                      <a:headEnd type="none" w="med" len="med"/>
+                      <a:tailEnd type="none" w="med" len="med"/>
+                    </a:lnL>
+                    <a:lnR w="6350" cap="flat" cmpd="sng" algn="ctr">
+                      <a:solidFill>
+                        <a:srgbClr val="CADCFC"/>
+                      </a:solidFill>
+                      <a:prstDash val="solid"/>
+                      <a:round/>
+                      <a:headEnd type="none" w="med" len="med"/>
+                      <a:tailEnd type="none" w="med" len="med"/>
+                    </a:lnR>
+                    <a:lnT w="6350" cap="flat" cmpd="sng" algn="ctr">
+                      <a:solidFill>
+                        <a:srgbClr val="CADCFC"/>
+                      </a:solidFill>
+                      <a:prstDash val="solid"/>
+                      <a:round/>
+                      <a:headEnd type="none" w="med" len="med"/>
+                      <a:tailEnd type="none" w="med" len="med"/>
+                    </a:lnT>
+                    <a:lnB w="6350" cap="flat" cmpd="sng" algn="ctr">
+                      <a:solidFill>
+                        <a:srgbClr val="CADCFC"/>
+                      </a:solidFill>
+                      <a:prstDash val="solid"/>
+                      <a:round/>
+                      <a:headEnd type="none" w="med" len="med"/>
+                      <a:tailEnd type="none" w="med" len="med"/>
+                    </a:lnB>
+                  </a:tcPr>
+                </a:tc>
+                <a:tc>
+                  <a:txBody>
+                    <a:bodyPr/>
+                    <a:lstStyle/>
+                    <a:p>
+                      <a:pPr indent="0" marL="0">
+                        <a:buNone/>
+                      </a:pPr>
+                      <a:r>
+                        <a:rPr lang="en-US" sz="1300" dirty="0">
+                          <a:solidFill>
+                            <a:srgbClr val="16203F"/>
+                          </a:solidFill>
+                          <a:latin typeface="Calibri" pitchFamily="34" charset="0"/>
+                          <a:ea typeface="Calibri" pitchFamily="34" charset="-122"/>
+                          <a:cs typeface="Calibri" pitchFamily="34" charset="-120"/>
+                        </a:rPr>
+                        <a:t>Agent + 2 tools</a:t>
+                      </a:r>
+                      <a:endParaRPr lang="en-US" sz="1300" dirty="0">
+                        <a:latin typeface="Calibri" charset="0"/>
+                        <a:ea typeface="Calibri" charset="0"/>
+                        <a:cs typeface="Calibri" charset="0"/>
+                      </a:endParaRPr>
+                    </a:p>
+                  </a:txBody>
+                  <a:tcPr marL="91440" marR="91440" marT="45720" marB="45720" anchor="ctr">
+                    <a:lnL w="6350" cap="flat" cmpd="sng" algn="ctr">
+                      <a:solidFill>
+                        <a:srgbClr val="CADCFC"/>
+                      </a:solidFill>
+                      <a:prstDash val="solid"/>
+                      <a:round/>
+                      <a:headEnd type="none" w="med" len="med"/>
+                      <a:tailEnd type="none" w="med" len="med"/>
+                    </a:lnL>
+                    <a:lnR w="6350" cap="flat" cmpd="sng" algn="ctr">
+                      <a:solidFill>
+                        <a:srgbClr val="CADCFC"/>
+                      </a:solidFill>
+                      <a:prstDash val="solid"/>
+                      <a:round/>
+                      <a:headEnd type="none" w="med" len="med"/>
+                      <a:tailEnd type="none" w="med" len="med"/>
+                    </a:lnR>
+                    <a:lnT w="6350" cap="flat" cmpd="sng" algn="ctr">
+                      <a:solidFill>
+                        <a:srgbClr val="CADCFC"/>
+                      </a:solidFill>
+                      <a:prstDash val="solid"/>
+                      <a:round/>
+                      <a:headEnd type="none" w="med" len="med"/>
+                      <a:tailEnd type="none" w="med" len="med"/>
+                    </a:lnT>
+                    <a:lnB w="6350" cap="flat" cmpd="sng" algn="ctr">
+                      <a:solidFill>
+                        <a:srgbClr val="CADCFC"/>
+                      </a:solidFill>
+                      <a:prstDash val="solid"/>
+                      <a:round/>
+                      <a:headEnd type="none" w="med" len="med"/>
+                      <a:tailEnd type="none" w="med" len="med"/>
+                    </a:lnB>
+                  </a:tcPr>
+                </a:tc>
+                <a:tc>
+                  <a:txBody>
+                    <a:bodyPr/>
+                    <a:lstStyle/>
+                    <a:p>
+                      <a:pPr indent="0" marL="0">
+                        <a:buNone/>
+                      </a:pPr>
+                      <a:r>
+                        <a:rPr lang="en-US" sz="1300" dirty="0">
+                          <a:solidFill>
+                            <a:srgbClr val="16203F"/>
+                          </a:solidFill>
+                          <a:latin typeface="Calibri" pitchFamily="34" charset="0"/>
+                          <a:ea typeface="Calibri" pitchFamily="34" charset="-122"/>
+                          <a:cs typeface="Calibri" pitchFamily="34" charset="-120"/>
+                        </a:rPr>
+                        <a:t>Plain RAG — can't compute reliably; misses the tool-use track</a:t>
+                      </a:r>
+                      <a:endParaRPr lang="en-US" sz="1300" dirty="0">
+                        <a:latin typeface="Calibri" charset="0"/>
+                        <a:ea typeface="Calibri" charset="0"/>
+                        <a:cs typeface="Calibri" charset="0"/>
+                      </a:endParaRPr>
+                    </a:p>
+                  </a:txBody>
+                  <a:tcPr marL="91440" marR="91440" marT="45720" marB="45720" anchor="ctr">
+                    <a:lnL w="6350" cap="flat" cmpd="sng" algn="ctr">
+                      <a:solidFill>
+                        <a:srgbClr val="CADCFC"/>
+                      </a:solidFill>
+                      <a:prstDash val="solid"/>
+                      <a:round/>
+                      <a:headEnd type="none" w="med" len="med"/>
+                      <a:tailEnd type="none" w="med" len="med"/>
+                    </a:lnL>
+                    <a:lnR w="6350" cap="flat" cmpd="sng" algn="ctr">
+                      <a:solidFill>
+                        <a:srgbClr val="CADCFC"/>
+                      </a:solidFill>
+                      <a:prstDash val="solid"/>
+                      <a:round/>
+                      <a:headEnd type="none" w="med" len="med"/>
+                      <a:tailEnd type="none" w="med" len="med"/>
+                    </a:lnR>
+                    <a:lnT w="6350" cap="flat" cmpd="sng" algn="ctr">
+                      <a:solidFill>
+                        <a:srgbClr val="CADCFC"/>
+                      </a:solidFill>
+                      <a:prstDash val="solid"/>
+                      <a:round/>
+                      <a:headEnd type="none" w="med" len="med"/>
+                      <a:tailEnd type="none" w="med" len="med"/>
+                    </a:lnT>
+                    <a:lnB w="6350" cap="flat" cmpd="sng" algn="ctr">
+                      <a:solidFill>
+                        <a:srgbClr val="CADCFC"/>
+                      </a:solidFill>
+                      <a:prstDash val="solid"/>
+                      <a:round/>
+                      <a:headEnd type="none" w="med" len="med"/>
+                      <a:tailEnd type="none" w="med" len="med"/>
+                    </a:lnB>
+                  </a:tcPr>
+                </a:tc>
+              </a:tr>
+              <a:tr h="640080">
+                <a:tc>
+                  <a:txBody>
+                    <a:bodyPr/>
+                    <a:lstStyle/>
+                    <a:p>
+                      <a:pPr indent="0" marL="0">
+                        <a:buNone/>
+                      </a:pPr>
+                      <a:r>
+                        <a:rPr lang="en-US" sz="1300" dirty="0">
+                          <a:solidFill>
+                            <a:srgbClr val="16203F"/>
+                          </a:solidFill>
+                          <a:latin typeface="Calibri" pitchFamily="34" charset="0"/>
+                          <a:ea typeface="Calibri" pitchFamily="34" charset="-122"/>
+                          <a:cs typeface="Calibri" pitchFamily="34" charset="-120"/>
+                        </a:rPr>
+                        <a:t>Doing math</a:t>
+                      </a:r>
+                      <a:endParaRPr lang="en-US" sz="1300" dirty="0">
+                        <a:latin typeface="Calibri" charset="0"/>
+                        <a:ea typeface="Calibri" charset="0"/>
+                        <a:cs typeface="Calibri" charset="0"/>
+                      </a:endParaRPr>
+                    </a:p>
+                  </a:txBody>
+                  <a:tcPr marL="91440" marR="91440" marT="45720" marB="45720" anchor="ctr">
+                    <a:lnL w="6350" cap="flat" cmpd="sng" algn="ctr">
+                      <a:solidFill>
+                        <a:srgbClr val="CADCFC"/>
+                      </a:solidFill>
+                      <a:prstDash val="solid"/>
+                      <a:round/>
+                      <a:headEnd type="none" w="med" len="med"/>
+                      <a:tailEnd type="none" w="med" len="med"/>
+                    </a:lnL>
+                    <a:lnR w="6350" cap="flat" cmpd="sng" algn="ctr">
+                      <a:solidFill>
+                        <a:srgbClr val="CADCFC"/>
+                      </a:solidFill>
+                      <a:prstDash val="solid"/>
+                      <a:round/>
+                      <a:headEnd type="none" w="med" len="med"/>
+                      <a:tailEnd type="none" w="med" len="med"/>
+                    </a:lnR>
+                    <a:lnT w="6350" cap="flat" cmpd="sng" algn="ctr">
+                      <a:solidFill>
+                        <a:srgbClr val="CADCFC"/>
+                      </a:solidFill>
+                      <a:prstDash val="solid"/>
+                      <a:round/>
+                      <a:headEnd type="none" w="med" len="med"/>
+                      <a:tailEnd type="none" w="med" len="med"/>
+                    </a:lnT>
+                    <a:lnB w="6350" cap="flat" cmpd="sng" algn="ctr">
+                      <a:solidFill>
+                        <a:srgbClr val="CADCFC"/>
+                      </a:solidFill>
+                      <a:prstDash val="solid"/>
+                      <a:round/>
+                      <a:headEnd type="none" w="med" len="med"/>
+                      <a:tailEnd type="none" w="med" len="med"/>
+                    </a:lnB>
+                  </a:tcPr>
+                </a:tc>
+                <a:tc>
+                  <a:txBody>
+                    <a:bodyPr/>
+                    <a:lstStyle/>
+                    <a:p>
+                      <a:pPr indent="0" marL="0">
+                        <a:buNone/>
+                      </a:pPr>
+                      <a:r>
+                        <a:rPr lang="en-US" sz="1300" dirty="0">
+                          <a:solidFill>
+                            <a:srgbClr val="16203F"/>
+                          </a:solidFill>
+                          <a:latin typeface="Calibri" pitchFamily="34" charset="0"/>
+                          <a:ea typeface="Calibri" pitchFamily="34" charset="-122"/>
+                          <a:cs typeface="Calibri" pitchFamily="34" charset="-120"/>
+                        </a:rPr>
+                        <a:t>calculator tool</a:t>
+                      </a:r>
+                      <a:endParaRPr lang="en-US" sz="1300" dirty="0">
+                        <a:latin typeface="Calibri" charset="0"/>
+                        <a:ea typeface="Calibri" charset="0"/>
+                        <a:cs typeface="Calibri" charset="0"/>
+                      </a:endParaRPr>
+                    </a:p>
+                  </a:txBody>
+                  <a:tcPr marL="91440" marR="91440" marT="45720" marB="45720" anchor="ctr">
+                    <a:lnL w="6350" cap="flat" cmpd="sng" algn="ctr">
+                      <a:solidFill>
+                        <a:srgbClr val="CADCFC"/>
+                      </a:solidFill>
+                      <a:prstDash val="solid"/>
+                      <a:round/>
+                      <a:headEnd type="none" w="med" len="med"/>
+                      <a:tailEnd type="none" w="med" len="med"/>
+                    </a:lnL>
+                    <a:lnR w="6350" cap="flat" cmpd="sng" algn="ctr">
+                      <a:solidFill>
+                        <a:srgbClr val="CADCFC"/>
+                      </a:solidFill>
+                      <a:prstDash val="solid"/>
+                      <a:round/>
+                      <a:headEnd type="none" w="med" len="med"/>
+                      <a:tailEnd type="none" w="med" len="med"/>
+                    </a:lnR>
+                    <a:lnT w="6350" cap="flat" cmpd="sng" algn="ctr">
+                      <a:solidFill>
+                        <a:srgbClr val="CADCFC"/>
+                      </a:solidFill>
+                      <a:prstDash val="solid"/>
+                      <a:round/>
+                      <a:headEnd type="none" w="med" len="med"/>
+                      <a:tailEnd type="none" w="med" len="med"/>
+                    </a:lnT>
+                    <a:lnB w="6350" cap="flat" cmpd="sng" algn="ctr">
+                      <a:solidFill>
+                        <a:srgbClr val="CADCFC"/>
+                      </a:solidFill>
+                      <a:prstDash val="solid"/>
+                      <a:round/>
+                      <a:headEnd type="none" w="med" len="med"/>
+                      <a:tailEnd type="none" w="med" len="med"/>
+                    </a:lnB>
+                  </a:tcPr>
+                </a:tc>
+                <a:tc>
+                  <a:txBody>
+                    <a:bodyPr/>
+                    <a:lstStyle/>
+                    <a:p>
+                      <a:pPr indent="0" marL="0">
+                        <a:buNone/>
+                      </a:pPr>
+                      <a:r>
+                        <a:rPr lang="en-US" sz="1300" dirty="0">
+                          <a:solidFill>
+                            <a:srgbClr val="16203F"/>
+                          </a:solidFill>
+                          <a:latin typeface="Calibri" pitchFamily="34" charset="0"/>
+                          <a:ea typeface="Calibri" pitchFamily="34" charset="-122"/>
+                          <a:cs typeface="Calibri" pitchFamily="34" charset="-120"/>
+                        </a:rPr>
+                        <a:t>LLM mental math — miscalculates, not auditable</a:t>
+                      </a:r>
+                      <a:endParaRPr lang="en-US" sz="1300" dirty="0">
+                        <a:latin typeface="Calibri" charset="0"/>
+                        <a:ea typeface="Calibri" charset="0"/>
+                        <a:cs typeface="Calibri" charset="0"/>
+                      </a:endParaRPr>
+                    </a:p>
+                  </a:txBody>
+                  <a:tcPr marL="91440" marR="91440" marT="45720" marB="45720" anchor="ctr">
+                    <a:lnL w="6350" cap="flat" cmpd="sng" algn="ctr">
+                      <a:solidFill>
+                        <a:srgbClr val="CADCFC"/>
+                      </a:solidFill>
+                      <a:prstDash val="solid"/>
+                      <a:round/>
+                      <a:headEnd type="none" w="med" len="med"/>
+                      <a:tailEnd type="none" w="med" len="med"/>
+                    </a:lnL>
+                    <a:lnR w="6350" cap="flat" cmpd="sng" algn="ctr">
+                      <a:solidFill>
+                        <a:srgbClr val="CADCFC"/>
+                      </a:solidFill>
+                      <a:prstDash val="solid"/>
+                      <a:round/>
+                      <a:headEnd type="none" w="med" len="med"/>
+                      <a:tailEnd type="none" w="med" len="med"/>
+                    </a:lnR>
+                    <a:lnT w="6350" cap="flat" cmpd="sng" algn="ctr">
+                      <a:solidFill>
+                        <a:srgbClr val="CADCFC"/>
+                      </a:solidFill>
+                      <a:prstDash val="solid"/>
+                      <a:round/>
+                      <a:headEnd type="none" w="med" len="med"/>
+                      <a:tailEnd type="none" w="med" len="med"/>
+                    </a:lnT>
+                    <a:lnB w="6350" cap="flat" cmpd="sng" algn="ctr">
+                      <a:solidFill>
+                        <a:srgbClr val="CADCFC"/>
+                      </a:solidFill>
+                      <a:prstDash val="solid"/>
+                      <a:round/>
+                      <a:headEnd type="none" w="med" len="med"/>
+                      <a:tailEnd type="none" w="med" len="med"/>
+                    </a:lnB>
+                  </a:tcPr>
+                </a:tc>
+              </a:tr>
+              <a:tr h="640080">
+                <a:tc>
+                  <a:txBody>
+                    <a:bodyPr/>
+                    <a:lstStyle/>
+                    <a:p>
+                      <a:pPr indent="0" marL="0">
+                        <a:buNone/>
+                      </a:pPr>
+                      <a:r>
+                        <a:rPr lang="en-US" sz="1300" dirty="0">
+                          <a:solidFill>
+                            <a:srgbClr val="16203F"/>
+                          </a:solidFill>
+                          <a:latin typeface="Calibri" pitchFamily="34" charset="0"/>
+                          <a:ea typeface="Calibri" pitchFamily="34" charset="-122"/>
+                          <a:cs typeface="Calibri" pitchFamily="34" charset="-120"/>
+                        </a:rPr>
+                        <a:t>Data source</a:t>
+                      </a:r>
+                      <a:endParaRPr lang="en-US" sz="1300" dirty="0">
+                        <a:latin typeface="Calibri" charset="0"/>
+                        <a:ea typeface="Calibri" charset="0"/>
+                        <a:cs typeface="Calibri" charset="0"/>
+                      </a:endParaRPr>
+                    </a:p>
+                  </a:txBody>
+                  <a:tcPr marL="91440" marR="91440" marT="45720" marB="45720" anchor="ctr">
+                    <a:lnL w="6350" cap="flat" cmpd="sng" algn="ctr">
+                      <a:solidFill>
+                        <a:srgbClr val="CADCFC"/>
+                      </a:solidFill>
+                      <a:prstDash val="solid"/>
+                      <a:round/>
+                      <a:headEnd type="none" w="med" len="med"/>
+                      <a:tailEnd type="none" w="med" len="med"/>
+                    </a:lnL>
+                    <a:lnR w="6350" cap="flat" cmpd="sng" algn="ctr">
+                      <a:solidFill>
+                        <a:srgbClr val="CADCFC"/>
+                      </a:solidFill>
+                      <a:prstDash val="solid"/>
+                      <a:round/>
+                      <a:headEnd type="none" w="med" len="med"/>
+                      <a:tailEnd type="none" w="med" len="med"/>
+                    </a:lnR>
+                    <a:lnT w="6350" cap="flat" cmpd="sng" algn="ctr">
+                      <a:solidFill>
+                        <a:srgbClr val="CADCFC"/>
+                      </a:solidFill>
+                      <a:prstDash val="solid"/>
+                      <a:round/>
+                      <a:headEnd type="none" w="med" len="med"/>
+                      <a:tailEnd type="none" w="med" len="med"/>
+                    </a:lnT>
+                    <a:lnB w="6350" cap="flat" cmpd="sng" algn="ctr">
+                      <a:solidFill>
+                        <a:srgbClr val="CADCFC"/>
+                      </a:solidFill>
+                      <a:prstDash val="solid"/>
+                      <a:round/>
+                      <a:headEnd type="none" w="med" len="med"/>
+                      <a:tailEnd type="none" w="med" len="med"/>
+                    </a:lnB>
+                  </a:tcPr>
+                </a:tc>
+                <a:tc>
+                  <a:txBody>
+                    <a:bodyPr/>
+                    <a:lstStyle/>
+                    <a:p>
+                      <a:pPr indent="0" marL="0">
+                        <a:buNone/>
+                      </a:pPr>
+                      <a:r>
+                        <a:rPr lang="en-US" sz="1300" dirty="0">
+                          <a:solidFill>
+                            <a:srgbClr val="16203F"/>
+                          </a:solidFill>
+                          <a:latin typeface="Calibri" pitchFamily="34" charset="0"/>
+                          <a:ea typeface="Calibri" pitchFamily="34" charset="-122"/>
+                          <a:cs typeface="Calibri" pitchFamily="34" charset="-120"/>
+                        </a:rPr>
+                        <a:t>EUR-Lex (Reg. 2023/1803)</a:t>
+                      </a:r>
+                      <a:endParaRPr lang="en-US" sz="1300" dirty="0">
+                        <a:latin typeface="Calibri" charset="0"/>
+                        <a:ea typeface="Calibri" charset="0"/>
+                        <a:cs typeface="Calibri" charset="0"/>
+                      </a:endParaRPr>
+                    </a:p>
+                  </a:txBody>
+                  <a:tcPr marL="91440" marR="91440" marT="45720" marB="45720" anchor="ctr">
+                    <a:lnL w="6350" cap="flat" cmpd="sng" algn="ctr">
+                      <a:solidFill>
+                        <a:srgbClr val="CADCFC"/>
+                      </a:solidFill>
+                      <a:prstDash val="solid"/>
+                      <a:round/>
+                      <a:headEnd type="none" w="med" len="med"/>
+                      <a:tailEnd type="none" w="med" len="med"/>
+                    </a:lnL>
+                    <a:lnR w="6350" cap="flat" cmpd="sng" algn="ctr">
+                      <a:solidFill>
+                        <a:srgbClr val="CADCFC"/>
+                      </a:solidFill>
+                      <a:prstDash val="solid"/>
+                      <a:round/>
+                      <a:headEnd type="none" w="med" len="med"/>
+                      <a:tailEnd type="none" w="med" len="med"/>
+                    </a:lnR>
+                    <a:lnT w="6350" cap="flat" cmpd="sng" algn="ctr">
+                      <a:solidFill>
+                        <a:srgbClr val="CADCFC"/>
+                      </a:solidFill>
+                      <a:prstDash val="solid"/>
+                      <a:round/>
+                      <a:headEnd type="none" w="med" len="med"/>
+                      <a:tailEnd type="none" w="med" len="med"/>
+                    </a:lnT>
+                    <a:lnB w="6350" cap="flat" cmpd="sng" algn="ctr">
+                      <a:solidFill>
+                        <a:srgbClr val="CADCFC"/>
+                      </a:solidFill>
+                      <a:prstDash val="solid"/>
+                      <a:round/>
+                      <a:headEnd type="none" w="med" len="med"/>
+                      <a:tailEnd type="none" w="med" len="med"/>
+                    </a:lnB>
+                  </a:tcPr>
+                </a:tc>
+                <a:tc>
+                  <a:txBody>
+                    <a:bodyPr/>
+                    <a:lstStyle/>
+                    <a:p>
+                      <a:pPr indent="0" marL="0">
+                        <a:buNone/>
+                      </a:pPr>
+                      <a:r>
+                        <a:rPr lang="en-US" sz="1300" dirty="0">
+                          <a:solidFill>
+                            <a:srgbClr val="16203F"/>
+                          </a:solidFill>
+                          <a:latin typeface="Calibri" pitchFamily="34" charset="0"/>
+                          <a:ea typeface="Calibri" pitchFamily="34" charset="-122"/>
+                          <a:cs typeface="Calibri" pitchFamily="34" charset="-120"/>
+                        </a:rPr>
+                        <a:t>ifrs.org texts — copyrighted, not redistributable</a:t>
+                      </a:r>
+                      <a:endParaRPr lang="en-US" sz="1300" dirty="0">
+                        <a:latin typeface="Calibri" charset="0"/>
+                        <a:ea typeface="Calibri" charset="0"/>
+                        <a:cs typeface="Calibri" charset="0"/>
+                      </a:endParaRPr>
+                    </a:p>
+                  </a:txBody>
+                  <a:tcPr marL="91440" marR="91440" marT="45720" marB="45720" anchor="ctr">
+                    <a:lnL w="6350" cap="flat" cmpd="sng" algn="ctr">
+                      <a:solidFill>
+                        <a:srgbClr val="CADCFC"/>
+                      </a:solidFill>
+                      <a:prstDash val="solid"/>
+                      <a:round/>
+                      <a:headEnd type="none" w="med" len="med"/>
+                      <a:tailEnd type="none" w="med" len="med"/>
+                    </a:lnL>
+                    <a:lnR w="6350" cap="flat" cmpd="sng" algn="ctr">
+                      <a:solidFill>
+                        <a:srgbClr val="CADCFC"/>
+                      </a:solidFill>
+                      <a:prstDash val="solid"/>
+                      <a:round/>
+                      <a:headEnd type="none" w="med" len="med"/>
+                      <a:tailEnd type="none" w="med" len="med"/>
+                    </a:lnR>
+                    <a:lnT w="6350" cap="flat" cmpd="sng" algn="ctr">
+                      <a:solidFill>
+                        <a:srgbClr val="CADCFC"/>
+                      </a:solidFill>
+                      <a:prstDash val="solid"/>
+                      <a:round/>
+                      <a:headEnd type="none" w="med" len="med"/>
+                      <a:tailEnd type="none" w="med" len="med"/>
+                    </a:lnT>
+                    <a:lnB w="6350" cap="flat" cmpd="sng" algn="ctr">
+                      <a:solidFill>
+                        <a:srgbClr val="CADCFC"/>
+                      </a:solidFill>
+                      <a:prstDash val="solid"/>
+                      <a:round/>
+                      <a:headEnd type="none" w="med" len="med"/>
+                      <a:tailEnd type="none" w="med" len="med"/>
+                    </a:lnB>
+                  </a:tcPr>
+                </a:tc>
+              </a:tr>
+              <a:tr h="640080">
+                <a:tc>
+                  <a:txBody>
+                    <a:bodyPr/>
+                    <a:lstStyle/>
+                    <a:p>
+                      <a:pPr indent="0" marL="0">
+                        <a:buNone/>
+                      </a:pPr>
+                      <a:r>
+                        <a:rPr lang="en-US" sz="1300" dirty="0">
+                          <a:solidFill>
+                            <a:srgbClr val="16203F"/>
+                          </a:solidFill>
+                          <a:latin typeface="Calibri" pitchFamily="34" charset="0"/>
+                          <a:ea typeface="Calibri" pitchFamily="34" charset="-122"/>
+                          <a:cs typeface="Calibri" pitchFamily="34" charset="-120"/>
+                        </a:rPr>
+                        <a:t>LLM</a:t>
+                      </a:r>
+                      <a:endParaRPr lang="en-US" sz="1300" dirty="0">
+                        <a:latin typeface="Calibri" charset="0"/>
+                        <a:ea typeface="Calibri" charset="0"/>
+                        <a:cs typeface="Calibri" charset="0"/>
+                      </a:endParaRPr>
+                    </a:p>
+                  </a:txBody>
+                  <a:tcPr marL="91440" marR="91440" marT="45720" marB="45720" anchor="ctr">
+                    <a:lnL w="6350" cap="flat" cmpd="sng" algn="ctr">
+                      <a:solidFill>
+                        <a:srgbClr val="CADCFC"/>
+                      </a:solidFill>
+                      <a:prstDash val="solid"/>
+                      <a:round/>
+                      <a:headEnd type="none" w="med" len="med"/>
+                      <a:tailEnd type="none" w="med" len="med"/>
+                    </a:lnL>
+                    <a:lnR w="6350" cap="flat" cmpd="sng" algn="ctr">
+                      <a:solidFill>
+                        <a:srgbClr val="CADCFC"/>
+                      </a:solidFill>
+                      <a:prstDash val="solid"/>
+                      <a:round/>
+                      <a:headEnd type="none" w="med" len="med"/>
+                      <a:tailEnd type="none" w="med" len="med"/>
+                    </a:lnR>
+                    <a:lnT w="6350" cap="flat" cmpd="sng" algn="ctr">
+                      <a:solidFill>
+                        <a:srgbClr val="CADCFC"/>
+                      </a:solidFill>
+                      <a:prstDash val="solid"/>
+                      <a:round/>
+                      <a:headEnd type="none" w="med" len="med"/>
+                      <a:tailEnd type="none" w="med" len="med"/>
+                    </a:lnT>
+                    <a:lnB w="6350" cap="flat" cmpd="sng" algn="ctr">
+                      <a:solidFill>
+                        <a:srgbClr val="CADCFC"/>
+                      </a:solidFill>
+                      <a:prstDash val="solid"/>
+                      <a:round/>
+                      <a:headEnd type="none" w="med" len="med"/>
+                      <a:tailEnd type="none" w="med" len="med"/>
+                    </a:lnB>
+                  </a:tcPr>
+                </a:tc>
+                <a:tc>
+                  <a:txBody>
+                    <a:bodyPr/>
+                    <a:lstStyle/>
+                    <a:p>
+                      <a:pPr indent="0" marL="0">
+                        <a:buNone/>
+                      </a:pPr>
+                      <a:r>
+                        <a:rPr lang="en-US" sz="1300" dirty="0">
+                          <a:solidFill>
+                            <a:srgbClr val="16203F"/>
+                          </a:solidFill>
+                          <a:latin typeface="Calibri" pitchFamily="34" charset="0"/>
+                          <a:ea typeface="Calibri" pitchFamily="34" charset="-122"/>
+                          <a:cs typeface="Calibri" pitchFamily="34" charset="-120"/>
+                        </a:rPr>
+                        <a:t>gemini-2.5-flash-lite</a:t>
+                      </a:r>
+                      <a:endParaRPr lang="en-US" sz="1300" dirty="0">
+                        <a:latin typeface="Calibri" charset="0"/>
+                        <a:ea typeface="Calibri" charset="0"/>
+                        <a:cs typeface="Calibri" charset="0"/>
+                      </a:endParaRPr>
+                    </a:p>
+                  </a:txBody>
+                  <a:tcPr marL="91440" marR="91440" marT="45720" marB="45720" anchor="ctr">
+                    <a:lnL w="6350" cap="flat" cmpd="sng" algn="ctr">
+                      <a:solidFill>
+                        <a:srgbClr val="CADCFC"/>
+                      </a:solidFill>
+                      <a:prstDash val="solid"/>
+                      <a:round/>
+                      <a:headEnd type="none" w="med" len="med"/>
+                      <a:tailEnd type="none" w="med" len="med"/>
+                    </a:lnL>
+                    <a:lnR w="6350" cap="flat" cmpd="sng" algn="ctr">
+                      <a:solidFill>
+                        <a:srgbClr val="CADCFC"/>
+                      </a:solidFill>
+                      <a:prstDash val="solid"/>
+                      <a:round/>
+                      <a:headEnd type="none" w="med" len="med"/>
+                      <a:tailEnd type="none" w="med" len="med"/>
+                    </a:lnR>
+                    <a:lnT w="6350" cap="flat" cmpd="sng" algn="ctr">
+                      <a:solidFill>
+                        <a:srgbClr val="CADCFC"/>
+                      </a:solidFill>
+                      <a:prstDash val="solid"/>
+                      <a:round/>
+                      <a:headEnd type="none" w="med" len="med"/>
+                      <a:tailEnd type="none" w="med" len="med"/>
+                    </a:lnT>
+                    <a:lnB w="6350" cap="flat" cmpd="sng" algn="ctr">
+                      <a:solidFill>
+                        <a:srgbClr val="CADCFC"/>
+                      </a:solidFill>
+                      <a:prstDash val="solid"/>
+                      <a:round/>
+                      <a:headEnd type="none" w="med" len="med"/>
+                      <a:tailEnd type="none" w="med" len="med"/>
+                    </a:lnB>
+                  </a:tcPr>
+                </a:tc>
+                <a:tc>
+                  <a:txBody>
+                    <a:bodyPr/>
+                    <a:lstStyle/>
+                    <a:p>
+                      <a:pPr indent="0" marL="0">
+                        <a:buNone/>
+                      </a:pPr>
+                      <a:r>
+                        <a:rPr lang="en-US" sz="1300" dirty="0">
+                          <a:solidFill>
+                            <a:srgbClr val="16203F"/>
+                          </a:solidFill>
+                          <a:latin typeface="Calibri" pitchFamily="34" charset="0"/>
+                          <a:ea typeface="Calibri" pitchFamily="34" charset="-122"/>
+                          <a:cs typeface="Calibri" pitchFamily="34" charset="-120"/>
+                        </a:rPr>
+                        <a:t>gemini-3.x — breaks course LangChain; bigger — no free quota</a:t>
+                      </a:r>
+                      <a:endParaRPr lang="en-US" sz="1300" dirty="0">
+                        <a:latin typeface="Calibri" charset="0"/>
+                        <a:ea typeface="Calibri" charset="0"/>
+                        <a:cs typeface="Calibri" charset="0"/>
+                      </a:endParaRPr>
+                    </a:p>
+                  </a:txBody>
+                  <a:tcPr marL="91440" marR="91440" marT="45720" marB="45720" anchor="ctr">
+                    <a:lnL w="6350" cap="flat" cmpd="sng" algn="ctr">
+                      <a:solidFill>
+                        <a:srgbClr val="CADCFC"/>
+                      </a:solidFill>
+                      <a:prstDash val="solid"/>
+                      <a:round/>
+                      <a:headEnd type="none" w="med" len="med"/>
+                      <a:tailEnd type="none" w="med" len="med"/>
+                    </a:lnL>
+                    <a:lnR w="6350" cap="flat" cmpd="sng" algn="ctr">
+                      <a:solidFill>
+                        <a:srgbClr val="CADCFC"/>
+                      </a:solidFill>
+                      <a:prstDash val="solid"/>
+                      <a:round/>
+                      <a:headEnd type="none" w="med" len="med"/>
+                      <a:tailEnd type="none" w="med" len="med"/>
+                    </a:lnR>
+                    <a:lnT w="6350" cap="flat" cmpd="sng" algn="ctr">
+                      <a:solidFill>
+                        <a:srgbClr val="CADCFC"/>
+                      </a:solidFill>
+                      <a:prstDash val="solid"/>
+                      <a:round/>
+                      <a:headEnd type="none" w="med" len="med"/>
+                      <a:tailEnd type="none" w="med" len="med"/>
+                    </a:lnT>
+                    <a:lnB w="6350" cap="flat" cmpd="sng" algn="ctr">
+                      <a:solidFill>
+                        <a:srgbClr val="CADCFC"/>
+                      </a:solidFill>
+                      <a:prstDash val="solid"/>
+                      <a:round/>
+                      <a:headEnd type="none" w="med" len="med"/>
+                      <a:tailEnd type="none" w="med" len="med"/>
+                    </a:lnB>
+                  </a:tcPr>
+                </a:tc>
+              </a:tr>
+              <a:tr h="640080">
+                <a:tc>
+                  <a:txBody>
+                    <a:bodyPr/>
+                    <a:lstStyle/>
+                    <a:p>
+                      <a:pPr indent="0" marL="0">
+                        <a:buNone/>
+                      </a:pPr>
+                      <a:r>
+                        <a:rPr lang="en-US" sz="1300" dirty="0">
+                          <a:solidFill>
+                            <a:srgbClr val="16203F"/>
+                          </a:solidFill>
+                          <a:latin typeface="Calibri" pitchFamily="34" charset="0"/>
+                          <a:ea typeface="Calibri" pitchFamily="34" charset="-122"/>
+                          <a:cs typeface="Calibri" pitchFamily="34" charset="-120"/>
+                        </a:rPr>
+                        <a:t>Chunking</a:t>
+                      </a:r>
+                      <a:endParaRPr lang="en-US" sz="1300" dirty="0">
+                        <a:latin typeface="Calibri" charset="0"/>
+                        <a:ea typeface="Calibri" charset="0"/>
+                        <a:cs typeface="Calibri" charset="0"/>
+                      </a:endParaRPr>
+                    </a:p>
+                  </a:txBody>
+                  <a:tcPr marL="91440" marR="91440" marT="45720" marB="45720" anchor="ctr">
+                    <a:lnL w="6350" cap="flat" cmpd="sng" algn="ctr">
+                      <a:solidFill>
+                        <a:srgbClr val="CADCFC"/>
+                      </a:solidFill>
+                      <a:prstDash val="solid"/>
+                      <a:round/>
+                      <a:headEnd type="none" w="med" len="med"/>
+                      <a:tailEnd type="none" w="med" len="med"/>
+                    </a:lnL>
+                    <a:lnR w="6350" cap="flat" cmpd="sng" algn="ctr">
+                      <a:solidFill>
+                        <a:srgbClr val="CADCFC"/>
+                      </a:solidFill>
+                      <a:prstDash val="solid"/>
+                      <a:round/>
+                      <a:headEnd type="none" w="med" len="med"/>
+                      <a:tailEnd type="none" w="med" len="med"/>
+                    </a:lnR>
+                    <a:lnT w="6350" cap="flat" cmpd="sng" algn="ctr">
+                      <a:solidFill>
+                        <a:srgbClr val="CADCFC"/>
+                      </a:solidFill>
+                      <a:prstDash val="solid"/>
+                      <a:round/>
+                      <a:headEnd type="none" w="med" len="med"/>
+                      <a:tailEnd type="none" w="med" len="med"/>
+                    </a:lnT>
+                    <a:lnB w="6350" cap="flat" cmpd="sng" algn="ctr">
+                      <a:solidFill>
+                        <a:srgbClr val="CADCFC"/>
+                      </a:solidFill>
+                      <a:prstDash val="solid"/>
+                      <a:round/>
+                      <a:headEnd type="none" w="med" len="med"/>
+                      <a:tailEnd type="none" w="med" len="med"/>
+                    </a:lnB>
+                  </a:tcPr>
+                </a:tc>
+                <a:tc>
+                  <a:txBody>
+                    <a:bodyPr/>
+                    <a:lstStyle/>
+                    <a:p>
+                      <a:pPr indent="0" marL="0">
+                        <a:buNone/>
+                      </a:pPr>
+                      <a:r>
+                        <a:rPr lang="en-US" sz="1300" dirty="0">
+                          <a:solidFill>
+                            <a:srgbClr val="16203F"/>
+                          </a:solidFill>
+                          <a:latin typeface="Calibri" pitchFamily="34" charset="0"/>
+                          <a:ea typeface="Calibri" pitchFamily="34" charset="-122"/>
+                          <a:cs typeface="Calibri" pitchFamily="34" charset="-120"/>
+                        </a:rPr>
+                        <a:t>by section heading</a:t>
+                      </a:r>
+                      <a:endParaRPr lang="en-US" sz="1300" dirty="0">
+                        <a:latin typeface="Calibri" charset="0"/>
+                        <a:ea typeface="Calibri" charset="0"/>
+                        <a:cs typeface="Calibri" charset="0"/>
+                      </a:endParaRPr>
+                    </a:p>
+                  </a:txBody>
+                  <a:tcPr marL="91440" marR="91440" marT="45720" marB="45720" anchor="ctr">
+                    <a:lnL w="6350" cap="flat" cmpd="sng" algn="ctr">
+                      <a:solidFill>
+                        <a:srgbClr val="CADCFC"/>
+                      </a:solidFill>
+                      <a:prstDash val="solid"/>
+                      <a:round/>
+                      <a:headEnd type="none" w="med" len="med"/>
+                      <a:tailEnd type="none" w="med" len="med"/>
+                    </a:lnL>
+                    <a:lnR w="6350" cap="flat" cmpd="sng" algn="ctr">
+                      <a:solidFill>
+                        <a:srgbClr val="CADCFC"/>
+                      </a:solidFill>
+                      <a:prstDash val="solid"/>
+                      <a:round/>
+                      <a:headEnd type="none" w="med" len="med"/>
+                      <a:tailEnd type="none" w="med" len="med"/>
+                    </a:lnR>
+                    <a:lnT w="6350" cap="flat" cmpd="sng" algn="ctr">
+                      <a:solidFill>
+                        <a:srgbClr val="CADCFC"/>
+                      </a:solidFill>
+                      <a:prstDash val="solid"/>
+                      <a:round/>
+                      <a:headEnd type="none" w="med" len="med"/>
+                      <a:tailEnd type="none" w="med" len="med"/>
+                    </a:lnT>
+                    <a:lnB w="6350" cap="flat" cmpd="sng" algn="ctr">
+                      <a:solidFill>
+                        <a:srgbClr val="CADCFC"/>
+                      </a:solidFill>
+                      <a:prstDash val="solid"/>
+                      <a:round/>
+                      <a:headEnd type="none" w="med" len="med"/>
+                      <a:tailEnd type="none" w="med" len="med"/>
+                    </a:lnB>
+                  </a:tcPr>
+                </a:tc>
+                <a:tc>
+                  <a:txBody>
+                    <a:bodyPr/>
+                    <a:lstStyle/>
+                    <a:p>
+                      <a:pPr indent="0" marL="0">
+                        <a:buNone/>
+                      </a:pPr>
+                      <a:r>
+                        <a:rPr lang="en-US" sz="1300" dirty="0">
+                          <a:solidFill>
+                            <a:srgbClr val="16203F"/>
+                          </a:solidFill>
+                          <a:latin typeface="Calibri" pitchFamily="34" charset="0"/>
+                          <a:ea typeface="Calibri" pitchFamily="34" charset="-122"/>
+                          <a:cs typeface="Calibri" pitchFamily="34" charset="-120"/>
+                        </a:rPr>
+                        <a:t>fixed-size chunks — split paragraphs, blur citations</a:t>
+                      </a:r>
+                      <a:endParaRPr lang="en-US" sz="1300" dirty="0">
+                        <a:latin typeface="Calibri" charset="0"/>
+                        <a:ea typeface="Calibri" charset="0"/>
+                        <a:cs typeface="Calibri" charset="0"/>
+                      </a:endParaRPr>
+                    </a:p>
+                  </a:txBody>
+                  <a:tcPr marL="91440" marR="91440" marT="45720" marB="45720" anchor="ctr">
+                    <a:lnL w="6350" cap="flat" cmpd="sng" algn="ctr">
+                      <a:solidFill>
+                        <a:srgbClr val="CADCFC"/>
+                      </a:solidFill>
+                      <a:prstDash val="solid"/>
+                      <a:round/>
+                      <a:headEnd type="none" w="med" len="med"/>
+                      <a:tailEnd type="none" w="med" len="med"/>
+                    </a:lnL>
+                    <a:lnR w="6350" cap="flat" cmpd="sng" algn="ctr">
+                      <a:solidFill>
+                        <a:srgbClr val="CADCFC"/>
+                      </a:solidFill>
+                      <a:prstDash val="solid"/>
+                      <a:round/>
+                      <a:headEnd type="none" w="med" len="med"/>
+                      <a:tailEnd type="none" w="med" len="med"/>
+                    </a:lnR>
+                    <a:lnT w="6350" cap="flat" cmpd="sng" algn="ctr">
+                      <a:solidFill>
+                        <a:srgbClr val="CADCFC"/>
+                      </a:solidFill>
+                      <a:prstDash val="solid"/>
+                      <a:round/>
+                      <a:headEnd type="none" w="med" len="med"/>
+                      <a:tailEnd type="none" w="med" len="med"/>
+                    </a:lnT>
+                    <a:lnB w="6350" cap="flat" cmpd="sng" algn="ctr">
+                      <a:solidFill>
+                        <a:srgbClr val="CADCFC"/>
+                      </a:solidFill>
+                      <a:prstDash val="solid"/>
+                      <a:round/>
+                      <a:headEnd type="none" w="med" len="med"/>
+                      <a:tailEnd type="none" w="med" len="med"/>
+                    </a:lnB>
+                  </a:tcPr>
+                </a:tc>
+              </a:tr>
+              <a:tr h="640080">
+                <a:tc>
+                  <a:txBody>
+                    <a:bodyPr/>
+                    <a:lstStyle/>
+                    <a:p>
+                      <a:pPr indent="0" marL="0">
+                        <a:buNone/>
+                      </a:pPr>
+                      <a:r>
+                        <a:rPr lang="en-US" sz="1300" dirty="0">
+                          <a:solidFill>
+                            <a:srgbClr val="16203F"/>
+                          </a:solidFill>
+                          <a:latin typeface="Calibri" pitchFamily="34" charset="0"/>
+                          <a:ea typeface="Calibri" pitchFamily="34" charset="-122"/>
+                          <a:cs typeface="Calibri" pitchFamily="34" charset="-120"/>
+                        </a:rPr>
+                        <a:t>Vector store</a:t>
+                      </a:r>
+                      <a:endParaRPr lang="en-US" sz="1300" dirty="0">
+                        <a:latin typeface="Calibri" charset="0"/>
+                        <a:ea typeface="Calibri" charset="0"/>
+                        <a:cs typeface="Calibri" charset="0"/>
+                      </a:endParaRPr>
+                    </a:p>
+                  </a:txBody>
+                  <a:tcPr marL="91440" marR="91440" marT="45720" marB="45720" anchor="ctr">
+                    <a:lnL w="6350" cap="flat" cmpd="sng" algn="ctr">
+                      <a:solidFill>
+                        <a:srgbClr val="CADCFC"/>
+                      </a:solidFill>
+                      <a:prstDash val="solid"/>
+                      <a:round/>
+                      <a:headEnd type="none" w="med" len="med"/>
+                      <a:tailEnd type="none" w="med" len="med"/>
+                    </a:lnL>
+                    <a:lnR w="6350" cap="flat" cmpd="sng" algn="ctr">
+                      <a:solidFill>
+                        <a:srgbClr val="CADCFC"/>
+                      </a:solidFill>
+                      <a:prstDash val="solid"/>
+                      <a:round/>
+                      <a:headEnd type="none" w="med" len="med"/>
+                      <a:tailEnd type="none" w="med" len="med"/>
+                    </a:lnR>
+                    <a:lnT w="6350" cap="flat" cmpd="sng" algn="ctr">
+                      <a:solidFill>
+                        <a:srgbClr val="CADCFC"/>
+                      </a:solidFill>
+                      <a:prstDash val="solid"/>
+                      <a:round/>
+                      <a:headEnd type="none" w="med" len="med"/>
+                      <a:tailEnd type="none" w="med" len="med"/>
+                    </a:lnT>
+                    <a:lnB w="6350" cap="flat" cmpd="sng" algn="ctr">
+                      <a:solidFill>
+                        <a:srgbClr val="CADCFC"/>
+                      </a:solidFill>
+                      <a:prstDash val="solid"/>
+                      <a:round/>
+                      <a:headEnd type="none" w="med" len="med"/>
+                      <a:tailEnd type="none" w="med" len="med"/>
+                    </a:lnB>
+                  </a:tcPr>
+                </a:tc>
+                <a:tc>
+                  <a:txBody>
+                    <a:bodyPr/>
+                    <a:lstStyle/>
+                    <a:p>
+                      <a:pPr indent="0" marL="0">
+                        <a:buNone/>
+                      </a:pPr>
+                      <a:r>
+                        <a:rPr lang="en-US" sz="1300" dirty="0">
+                          <a:solidFill>
+                            <a:srgbClr val="16203F"/>
+                          </a:solidFill>
+                          <a:latin typeface="Calibri" pitchFamily="34" charset="0"/>
+                          <a:ea typeface="Calibri" pitchFamily="34" charset="-122"/>
+                          <a:cs typeface="Calibri" pitchFamily="34" charset="-120"/>
+                        </a:rPr>
+                        <a:t>FAISS (local)</a:t>
+                      </a:r>
+                      <a:endParaRPr lang="en-US" sz="1300" dirty="0">
+                        <a:latin typeface="Calibri" charset="0"/>
+                        <a:ea typeface="Calibri" charset="0"/>
+                        <a:cs typeface="Calibri" charset="0"/>
+                      </a:endParaRPr>
+                    </a:p>
+                  </a:txBody>
+                  <a:tcPr marL="91440" marR="91440" marT="45720" marB="45720" anchor="ctr">
+                    <a:lnL w="6350" cap="flat" cmpd="sng" algn="ctr">
+                      <a:solidFill>
+                        <a:srgbClr val="CADCFC"/>
+                      </a:solidFill>
+                      <a:prstDash val="solid"/>
+                      <a:round/>
+                      <a:headEnd type="none" w="med" len="med"/>
+                      <a:tailEnd type="none" w="med" len="med"/>
+                    </a:lnL>
+                    <a:lnR w="6350" cap="flat" cmpd="sng" algn="ctr">
+                      <a:solidFill>
+                        <a:srgbClr val="CADCFC"/>
+                      </a:solidFill>
+                      <a:prstDash val="solid"/>
+                      <a:round/>
+                      <a:headEnd type="none" w="med" len="med"/>
+                      <a:tailEnd type="none" w="med" len="med"/>
+                    </a:lnR>
+                    <a:lnT w="6350" cap="flat" cmpd="sng" algn="ctr">
+                      <a:solidFill>
+                        <a:srgbClr val="CADCFC"/>
+                      </a:solidFill>
+                      <a:prstDash val="solid"/>
+                      <a:round/>
+                      <a:headEnd type="none" w="med" len="med"/>
+                      <a:tailEnd type="none" w="med" len="med"/>
+                    </a:lnT>
+                    <a:lnB w="6350" cap="flat" cmpd="sng" algn="ctr">
+                      <a:solidFill>
+                        <a:srgbClr val="CADCFC"/>
+                      </a:solidFill>
+                      <a:prstDash val="solid"/>
+                      <a:round/>
+                      <a:headEnd type="none" w="med" len="med"/>
+                      <a:tailEnd type="none" w="med" len="med"/>
+                    </a:lnB>
+                  </a:tcPr>
+                </a:tc>
+                <a:tc>
+                  <a:txBody>
+                    <a:bodyPr/>
+                    <a:lstStyle/>
+                    <a:p>
+                      <a:pPr indent="0" marL="0">
+                        <a:buNone/>
+                      </a:pPr>
+                      <a:r>
+                        <a:rPr lang="en-US" sz="1300" dirty="0">
+                          <a:solidFill>
+                            <a:srgbClr val="16203F"/>
+                          </a:solidFill>
+                          <a:latin typeface="Calibri" pitchFamily="34" charset="0"/>
+                          <a:ea typeface="Calibri" pitchFamily="34" charset="-122"/>
+                          <a:cs typeface="Calibri" pitchFamily="34" charset="-120"/>
+                        </a:rPr>
+                        <a:t>hosted vector DB — extra setup, no benefit at this scale</a:t>
+                      </a:r>
+                      <a:endParaRPr lang="en-US" sz="1300" dirty="0">
+                        <a:latin typeface="Calibri" charset="0"/>
+                        <a:ea typeface="Calibri" charset="0"/>
+                        <a:cs typeface="Calibri" charset="0"/>
+                      </a:endParaRPr>
+                    </a:p>
+                  </a:txBody>
+                  <a:tcPr marL="91440" marR="91440" marT="45720" marB="45720" anchor="ctr">
+                    <a:lnL w="6350" cap="flat" cmpd="sng" algn="ctr">
+                      <a:solidFill>
+                        <a:srgbClr val="CADCFC"/>
+                      </a:solidFill>
+                      <a:prstDash val="solid"/>
+                      <a:round/>
+                      <a:headEnd type="none" w="med" len="med"/>
+                      <a:tailEnd type="none" w="med" len="med"/>
+                    </a:lnL>
+                    <a:lnR w="6350" cap="flat" cmpd="sng" algn="ctr">
+                      <a:solidFill>
+                        <a:srgbClr val="CADCFC"/>
+                      </a:solidFill>
+                      <a:prstDash val="solid"/>
+                      <a:round/>
+                      <a:headEnd type="none" w="med" len="med"/>
+                      <a:tailEnd type="none" w="med" len="med"/>
+                    </a:lnR>
+                    <a:lnT w="6350" cap="flat" cmpd="sng" algn="ctr">
+                      <a:solidFill>
+                        <a:srgbClr val="CADCFC"/>
+                      </a:solidFill>
+                      <a:prstDash val="solid"/>
+                      <a:round/>
+                      <a:headEnd type="none" w="med" len="med"/>
+                      <a:tailEnd type="none" w="med" len="med"/>
+                    </a:lnT>
+                    <a:lnB w="6350" cap="flat" cmpd="sng" algn="ctr">
+                      <a:solidFill>
+                        <a:srgbClr val="CADCFC"/>
+                      </a:solidFill>
+                      <a:prstDash val="solid"/>
+                      <a:round/>
+                      <a:headEnd type="none" w="med" len="med"/>
+                      <a:tailEnd type="none" w="med" len="med"/>
+                    </a:lnB>
+                  </a:tcPr>
+                </a:tc>
+              </a:tr>
+            </a:tbl>
+          </a:graphicData>
+        </a:graphic>
+      </p:graphicFrame>
+      <p:sp>
+        <p:nvSpPr>
+          <p:cNvPr id="4" name="Text 1"/>
+          <p:cNvSpPr/>
+          <p:nvPr/>
+        </p:nvSpPr>
+        <p:spPr>
+          <a:xfrm>
+            <a:off x="640080" y="5852160"/>
+            <a:ext cx="10881360" cy="457200"/>
           </a:xfrm>
           <a:prstGeom prst="rect">
             <a:avLst/>
@@ -6308,326 +8263,17 @@
               <a:buNone/>
             </a:pPr>
             <a:r>
-              <a:rPr lang="en-US" sz="1800" b="1" dirty="0">
+              <a:rPr lang="en-US" sz="1250" i="1" dirty="0">
                 <a:solidFill>
-                  <a:srgbClr val="1E2761"/>
-                </a:solidFill>
-                <a:latin typeface="Georgia" pitchFamily="34" charset="0"/>
-                <a:ea typeface="Georgia" pitchFamily="34" charset="-122"/>
-                <a:cs typeface="Georgia" pitchFamily="34" charset="-120"/>
-              </a:rPr>
-              <a:t>Test set — 30 questions with known answers</a:t>
-            </a:r>
-            <a:endParaRPr lang="en-US" sz="1800" dirty="0"/>
-          </a:p>
-        </p:txBody>
-      </p:sp>
-      <p:sp>
-        <p:nvSpPr>
-          <p:cNvPr id="5" name="Text 3"/>
-          <p:cNvSpPr/>
-          <p:nvPr/>
-        </p:nvSpPr>
-        <p:spPr>
-          <a:xfrm>
-            <a:off x="914400" y="2103120"/>
-            <a:ext cx="10332720" cy="1097280"/>
-          </a:xfrm>
-          <a:prstGeom prst="rect">
-            <a:avLst/>
-          </a:prstGeom>
-          <a:noFill/>
-          <a:ln/>
-        </p:spPr>
-        <p:txBody>
-          <a:bodyPr wrap="square" rtlCol="0" anchor="ctr"/>
-          <a:lstStyle/>
-          <a:p>
-            <a:pPr indent="0" marL="0">
-              <a:buNone/>
-            </a:pPr>
-            <a:r>
-              <a:rPr lang="en-US" sz="1550" dirty="0">
-                <a:solidFill>
-                  <a:srgbClr val="16203F"/>
+                  <a:srgbClr val="00A896"/>
                 </a:solidFill>
                 <a:latin typeface="Calibri" pitchFamily="34" charset="0"/>
                 <a:ea typeface="Calibri" pitchFamily="34" charset="-122"/>
                 <a:cs typeface="Calibri" pitchFamily="34" charset="-120"/>
               </a:rPr>
-              <a:t>15 definitions / scope   ·   12 calculations (exact numbers)   ·   3 out-of-scope traps (must refuse)</a:t>
-            </a:r>
-            <a:endParaRPr lang="en-US" sz="1550" dirty="0"/>
-          </a:p>
-        </p:txBody>
-      </p:sp>
-      <p:sp>
-        <p:nvSpPr>
-          <p:cNvPr id="6" name="Shape 4"/>
-          <p:cNvSpPr/>
-          <p:nvPr/>
-        </p:nvSpPr>
-        <p:spPr>
-          <a:xfrm>
-            <a:off x="640080" y="3611880"/>
-            <a:ext cx="5303520" cy="2377440"/>
-          </a:xfrm>
-          <a:prstGeom prst="rect">
-            <a:avLst/>
-          </a:prstGeom>
-          <a:solidFill>
-            <a:srgbClr val="FFFFFF"/>
-          </a:solidFill>
-          <a:ln w="12700">
-            <a:solidFill>
-              <a:srgbClr val="CADCFC"/>
-            </a:solidFill>
-            <a:prstDash val="solid"/>
-          </a:ln>
-          <a:effectLst>
-            <a:outerShdw sx="100000" sy="100000" kx="0" ky="0" algn="bl" rotWithShape="0" blurRad="76200" dist="25400" dir="8100000">
-              <a:srgbClr val="000000">
-                <a:alpha val="10000"/>
-              </a:srgbClr>
-            </a:outerShdw>
-          </a:effectLst>
-        </p:spPr>
-      </p:sp>
-      <p:sp>
-        <p:nvSpPr>
-          <p:cNvPr id="7" name="Text 5"/>
-          <p:cNvSpPr/>
-          <p:nvPr/>
-        </p:nvSpPr>
-        <p:spPr>
-          <a:xfrm>
-            <a:off x="914400" y="3794760"/>
-            <a:ext cx="4754880" cy="457200"/>
-          </a:xfrm>
-          <a:prstGeom prst="rect">
-            <a:avLst/>
-          </a:prstGeom>
-          <a:noFill/>
-          <a:ln/>
-        </p:spPr>
-        <p:txBody>
-          <a:bodyPr wrap="square" rtlCol="0" anchor="ctr"/>
-          <a:lstStyle/>
-          <a:p>
-            <a:pPr indent="0" marL="0">
-              <a:buNone/>
-            </a:pPr>
-            <a:r>
-              <a:rPr lang="en-US" sz="1700" b="1" dirty="0">
-                <a:solidFill>
-                  <a:srgbClr val="00A896"/>
-                </a:solidFill>
-                <a:latin typeface="Georgia" pitchFamily="34" charset="0"/>
-                <a:ea typeface="Georgia" pitchFamily="34" charset="-122"/>
-                <a:cs typeface="Georgia" pitchFamily="34" charset="-120"/>
-              </a:rPr>
-              <a:t>Quantitative</a:t>
-            </a:r>
-            <a:endParaRPr lang="en-US" sz="1700" dirty="0"/>
-          </a:p>
-        </p:txBody>
-      </p:sp>
-      <p:sp>
-        <p:nvSpPr>
-          <p:cNvPr id="8" name="Text 6"/>
-          <p:cNvSpPr/>
-          <p:nvPr/>
-        </p:nvSpPr>
-        <p:spPr>
-          <a:xfrm>
-            <a:off x="914400" y="4297680"/>
-            <a:ext cx="4754880" cy="1554480"/>
-          </a:xfrm>
-          <a:prstGeom prst="rect">
-            <a:avLst/>
-          </a:prstGeom>
-          <a:noFill/>
-          <a:ln/>
-        </p:spPr>
-        <p:txBody>
-          <a:bodyPr wrap="square" rtlCol="0" anchor="ctr"/>
-          <a:lstStyle/>
-          <a:p>
-            <a:pPr marL="342900" indent="-342900">
-              <a:spcAft>
-                <a:spcPts val="800"/>
-              </a:spcAft>
-              <a:buSzPct val="100000"/>
-              <a:buChar char="•"/>
-            </a:pPr>
-            <a:r>
-              <a:rPr lang="en-US" sz="1400" dirty="0">
-                <a:solidFill>
-                  <a:srgbClr val="16203F"/>
-                </a:solidFill>
-                <a:latin typeface="Calibri" pitchFamily="34" charset="0"/>
-                <a:ea typeface="Calibri" pitchFamily="34" charset="-122"/>
-                <a:cs typeface="Calibri" pitchFamily="34" charset="-120"/>
-              </a:rPr>
-              <a:t>rageval.py: similarity, ROUGE, BLEU, keyword P/R/F1</a:t>
-            </a:r>
-            <a:endParaRPr lang="en-US" sz="1400" dirty="0"/>
-          </a:p>
-          <a:p>
-            <a:pPr marL="342900" indent="-342900">
-              <a:spcAft>
-                <a:spcPts val="800"/>
-              </a:spcAft>
-              <a:buSzPct val="100000"/>
-              <a:buChar char="•"/>
-            </a:pPr>
-            <a:r>
-              <a:rPr lang="en-US" sz="1400" dirty="0">
-                <a:solidFill>
-                  <a:srgbClr val="16203F"/>
-                </a:solidFill>
-                <a:latin typeface="Calibri" pitchFamily="34" charset="0"/>
-                <a:ea typeface="Calibri" pitchFamily="34" charset="-122"/>
-                <a:cs typeface="Calibri" pitchFamily="34" charset="-120"/>
-              </a:rPr>
-              <a:t>Agent vs plain-RAG baseline, same model &amp; questions</a:t>
-            </a:r>
-            <a:endParaRPr lang="en-US" sz="1400" dirty="0"/>
-          </a:p>
-        </p:txBody>
-      </p:sp>
-      <p:sp>
-        <p:nvSpPr>
-          <p:cNvPr id="9" name="Shape 7"/>
-          <p:cNvSpPr/>
-          <p:nvPr/>
-        </p:nvSpPr>
-        <p:spPr>
-          <a:xfrm>
-            <a:off x="6217920" y="3611880"/>
-            <a:ext cx="5303520" cy="2377440"/>
-          </a:xfrm>
-          <a:prstGeom prst="rect">
-            <a:avLst/>
-          </a:prstGeom>
-          <a:solidFill>
-            <a:srgbClr val="FFFFFF"/>
-          </a:solidFill>
-          <a:ln w="12700">
-            <a:solidFill>
-              <a:srgbClr val="CADCFC"/>
-            </a:solidFill>
-            <a:prstDash val="solid"/>
-          </a:ln>
-          <a:effectLst>
-            <a:outerShdw sx="100000" sy="100000" kx="0" ky="0" algn="bl" rotWithShape="0" blurRad="76200" dist="25400" dir="8100000">
-              <a:srgbClr val="000000">
-                <a:alpha val="10000"/>
-              </a:srgbClr>
-            </a:outerShdw>
-          </a:effectLst>
-        </p:spPr>
-      </p:sp>
-      <p:sp>
-        <p:nvSpPr>
-          <p:cNvPr id="10" name="Text 8"/>
-          <p:cNvSpPr/>
-          <p:nvPr/>
-        </p:nvSpPr>
-        <p:spPr>
-          <a:xfrm>
-            <a:off x="6492240" y="3794760"/>
-            <a:ext cx="4754880" cy="457200"/>
-          </a:xfrm>
-          <a:prstGeom prst="rect">
-            <a:avLst/>
-          </a:prstGeom>
-          <a:noFill/>
-          <a:ln/>
-        </p:spPr>
-        <p:txBody>
-          <a:bodyPr wrap="square" rtlCol="0" anchor="ctr"/>
-          <a:lstStyle/>
-          <a:p>
-            <a:pPr indent="0" marL="0">
-              <a:buNone/>
-            </a:pPr>
-            <a:r>
-              <a:rPr lang="en-US" sz="1700" b="1" dirty="0">
-                <a:solidFill>
-                  <a:srgbClr val="00A896"/>
-                </a:solidFill>
-                <a:latin typeface="Georgia" pitchFamily="34" charset="0"/>
-                <a:ea typeface="Georgia" pitchFamily="34" charset="-122"/>
-                <a:cs typeface="Georgia" pitchFamily="34" charset="-120"/>
-              </a:rPr>
-              <a:t>Qualitative</a:t>
-            </a:r>
-            <a:endParaRPr lang="en-US" sz="1700" dirty="0"/>
-          </a:p>
-        </p:txBody>
-      </p:sp>
-      <p:sp>
-        <p:nvSpPr>
-          <p:cNvPr id="11" name="Text 9"/>
-          <p:cNvSpPr/>
-          <p:nvPr/>
-        </p:nvSpPr>
-        <p:spPr>
-          <a:xfrm>
-            <a:off x="6492240" y="4297680"/>
-            <a:ext cx="4754880" cy="1554480"/>
-          </a:xfrm>
-          <a:prstGeom prst="rect">
-            <a:avLst/>
-          </a:prstGeom>
-          <a:noFill/>
-          <a:ln/>
-        </p:spPr>
-        <p:txBody>
-          <a:bodyPr wrap="square" rtlCol="0" anchor="ctr"/>
-          <a:lstStyle/>
-          <a:p>
-            <a:pPr marL="342900" indent="-342900">
-              <a:spcAft>
-                <a:spcPts val="800"/>
-              </a:spcAft>
-              <a:buSzPct val="100000"/>
-              <a:buChar char="•"/>
-            </a:pPr>
-            <a:r>
-              <a:rPr lang="en-US" sz="1400" dirty="0">
-                <a:solidFill>
-                  <a:srgbClr val="16203F"/>
-                </a:solidFill>
-                <a:latin typeface="Calibri" pitchFamily="34" charset="0"/>
-                <a:ea typeface="Calibri" pitchFamily="34" charset="-122"/>
-                <a:cs typeface="Calibri" pitchFamily="34" charset="-120"/>
-              </a:rPr>
-              <a:t>LLM-as-judge: semantic equivalence + confidence</a:t>
-            </a:r>
-            <a:endParaRPr lang="en-US" sz="1400" dirty="0"/>
-          </a:p>
-          <a:p>
-            <a:pPr marL="342900" indent="-342900">
-              <a:spcAft>
-                <a:spcPts val="800"/>
-              </a:spcAft>
-              <a:buSzPct val="100000"/>
-              <a:buChar char="•"/>
-            </a:pPr>
-            <a:r>
-              <a:rPr lang="en-US" sz="1400" dirty="0">
-                <a:solidFill>
-                  <a:srgbClr val="16203F"/>
-                </a:solidFill>
-                <a:latin typeface="Calibri" pitchFamily="34" charset="0"/>
-                <a:ea typeface="Calibri" pitchFamily="34" charset="-122"/>
-                <a:cs typeface="Calibri" pitchFamily="34" charset="-120"/>
-              </a:rPr>
-              <a:t>Refusal accuracy + error analysis by category</a:t>
-            </a:r>
-            <a:endParaRPr lang="en-US" sz="1400" dirty="0"/>
+              <a:t>Same reasoning underlies the evaluation: agent vs plain-RAG baseline on the SAME model isolates the effect of tool use.</a:t>
+            </a:r>
+            <a:endParaRPr lang="en-US" sz="1250" dirty="0"/>
           </a:p>
         </p:txBody>
       </p:sp>
@@ -6696,7 +8342,7 @@
                 <a:ea typeface="Georgia" pitchFamily="34" charset="-122"/>
                 <a:cs typeface="Georgia" pitchFamily="34" charset="-120"/>
               </a:rPr>
-              <a:t>Results</a:t>
+              <a:t>Evaluation methodology</a:t>
             </a:r>
             <a:endParaRPr lang="en-US" sz="3000" dirty="0"/>
           </a:p>
@@ -6710,8 +8356,118 @@
         </p:nvSpPr>
         <p:spPr>
           <a:xfrm>
-            <a:off x="640080" y="1463040"/>
-            <a:ext cx="2606040" cy="1554480"/>
+            <a:off x="640080" y="1371600"/>
+            <a:ext cx="10881360" cy="2011680"/>
+          </a:xfrm>
+          <a:prstGeom prst="rect">
+            <a:avLst/>
+          </a:prstGeom>
+          <a:solidFill>
+            <a:srgbClr val="F4F7FB"/>
+          </a:solidFill>
+          <a:ln w="12700">
+            <a:solidFill>
+              <a:srgbClr val="CADCFC"/>
+            </a:solidFill>
+            <a:prstDash val="solid"/>
+          </a:ln>
+          <a:effectLst>
+            <a:outerShdw sx="100000" sy="100000" kx="0" ky="0" algn="bl" rotWithShape="0" blurRad="76200" dist="25400" dir="8100000">
+              <a:srgbClr val="000000">
+                <a:alpha val="10000"/>
+              </a:srgbClr>
+            </a:outerShdw>
+          </a:effectLst>
+        </p:spPr>
+      </p:sp>
+      <p:sp>
+        <p:nvSpPr>
+          <p:cNvPr id="4" name="Text 2"/>
+          <p:cNvSpPr/>
+          <p:nvPr/>
+        </p:nvSpPr>
+        <p:spPr>
+          <a:xfrm>
+            <a:off x="914400" y="1554480"/>
+            <a:ext cx="10332720" cy="457200"/>
+          </a:xfrm>
+          <a:prstGeom prst="rect">
+            <a:avLst/>
+          </a:prstGeom>
+          <a:noFill/>
+          <a:ln/>
+        </p:spPr>
+        <p:txBody>
+          <a:bodyPr wrap="square" rtlCol="0" anchor="ctr"/>
+          <a:lstStyle/>
+          <a:p>
+            <a:pPr indent="0" marL="0">
+              <a:buNone/>
+            </a:pPr>
+            <a:r>
+              <a:rPr lang="en-US" sz="1800" b="1" dirty="0">
+                <a:solidFill>
+                  <a:srgbClr val="1E2761"/>
+                </a:solidFill>
+                <a:latin typeface="Georgia" pitchFamily="34" charset="0"/>
+                <a:ea typeface="Georgia" pitchFamily="34" charset="-122"/>
+                <a:cs typeface="Georgia" pitchFamily="34" charset="-120"/>
+              </a:rPr>
+              <a:t>Test set — 30 questions with known answers</a:t>
+            </a:r>
+            <a:endParaRPr lang="en-US" sz="1800" dirty="0"/>
+          </a:p>
+        </p:txBody>
+      </p:sp>
+      <p:sp>
+        <p:nvSpPr>
+          <p:cNvPr id="5" name="Text 3"/>
+          <p:cNvSpPr/>
+          <p:nvPr/>
+        </p:nvSpPr>
+        <p:spPr>
+          <a:xfrm>
+            <a:off x="914400" y="2103120"/>
+            <a:ext cx="10332720" cy="1097280"/>
+          </a:xfrm>
+          <a:prstGeom prst="rect">
+            <a:avLst/>
+          </a:prstGeom>
+          <a:noFill/>
+          <a:ln/>
+        </p:spPr>
+        <p:txBody>
+          <a:bodyPr wrap="square" rtlCol="0" anchor="ctr"/>
+          <a:lstStyle/>
+          <a:p>
+            <a:pPr indent="0" marL="0">
+              <a:buNone/>
+            </a:pPr>
+            <a:r>
+              <a:rPr lang="en-US" sz="1550" dirty="0">
+                <a:solidFill>
+                  <a:srgbClr val="16203F"/>
+                </a:solidFill>
+                <a:latin typeface="Calibri" pitchFamily="34" charset="0"/>
+                <a:ea typeface="Calibri" pitchFamily="34" charset="-122"/>
+                <a:cs typeface="Calibri" pitchFamily="34" charset="-120"/>
+              </a:rPr>
+              <a:t>15 definitions / scope   ·   12 calculations (exact numbers)   ·   3 out-of-scope traps (must refuse)</a:t>
+            </a:r>
+            <a:endParaRPr lang="en-US" sz="1550" dirty="0"/>
+          </a:p>
+        </p:txBody>
+      </p:sp>
+      <p:sp>
+        <p:nvSpPr>
+          <p:cNvPr id="6" name="Shape 4"/>
+          <p:cNvSpPr/>
+          <p:nvPr/>
+        </p:nvSpPr>
+        <p:spPr>
+          <a:xfrm>
+            <a:off x="640080" y="3611880"/>
+            <a:ext cx="5303520" cy="2377440"/>
           </a:xfrm>
           <a:prstGeom prst="rect">
             <a:avLst/>
@@ -6736,14 +8492,14 @@
       </p:sp>
       <p:sp>
         <p:nvSpPr>
-          <p:cNvPr id="4" name="Text 2"/>
-          <p:cNvSpPr/>
-          <p:nvPr/>
-        </p:nvSpPr>
-        <p:spPr>
-          <a:xfrm>
-            <a:off x="640080" y="1627632"/>
-            <a:ext cx="2606040" cy="822960"/>
+          <p:cNvPr id="7" name="Text 5"/>
+          <p:cNvSpPr/>
+          <p:nvPr/>
+        </p:nvSpPr>
+        <p:spPr>
+          <a:xfrm>
+            <a:off x="914400" y="3794760"/>
+            <a:ext cx="4754880" cy="457200"/>
           </a:xfrm>
           <a:prstGeom prst="rect">
             <a:avLst/>
@@ -6755,34 +8511,34 @@
           <a:bodyPr wrap="square" rtlCol="0" anchor="ctr"/>
           <a:lstStyle/>
           <a:p>
-            <a:pPr algn="ctr" indent="0" marL="0">
+            <a:pPr indent="0" marL="0">
               <a:buNone/>
             </a:pPr>
             <a:r>
-              <a:rPr lang="en-US" sz="4000" b="1" dirty="0">
+              <a:rPr lang="en-US" sz="1700" b="1" dirty="0">
                 <a:solidFill>
-                  <a:srgbClr val="1E2761"/>
+                  <a:srgbClr val="00A896"/>
                 </a:solidFill>
                 <a:latin typeface="Georgia" pitchFamily="34" charset="0"/>
                 <a:ea typeface="Georgia" pitchFamily="34" charset="-122"/>
                 <a:cs typeface="Georgia" pitchFamily="34" charset="-120"/>
               </a:rPr>
-              <a:t>30 / 30</a:t>
-            </a:r>
-            <a:endParaRPr lang="en-US" sz="4000" dirty="0"/>
-          </a:p>
-        </p:txBody>
-      </p:sp>
-      <p:sp>
-        <p:nvSpPr>
-          <p:cNvPr id="5" name="Text 3"/>
-          <p:cNvSpPr/>
-          <p:nvPr/>
-        </p:nvSpPr>
-        <p:spPr>
-          <a:xfrm>
-            <a:off x="777240" y="2423160"/>
-            <a:ext cx="2331720" cy="502920"/>
+              <a:t>Quantitative</a:t>
+            </a:r>
+            <a:endParaRPr lang="en-US" sz="1700" dirty="0"/>
+          </a:p>
+        </p:txBody>
+      </p:sp>
+      <p:sp>
+        <p:nvSpPr>
+          <p:cNvPr id="8" name="Text 6"/>
+          <p:cNvSpPr/>
+          <p:nvPr/>
+        </p:nvSpPr>
+        <p:spPr>
+          <a:xfrm>
+            <a:off x="914400" y="4297680"/>
+            <a:ext cx="4754880" cy="1554480"/>
           </a:xfrm>
           <a:prstGeom prst="rect">
             <a:avLst/>
@@ -6794,34 +8550,59 @@
           <a:bodyPr wrap="square" rtlCol="0" anchor="ctr"/>
           <a:lstStyle/>
           <a:p>
-            <a:pPr algn="ctr" indent="0" marL="0">
-              <a:buNone/>
+            <a:pPr marL="342900" indent="-342900">
+              <a:spcAft>
+                <a:spcPts val="800"/>
+              </a:spcAft>
+              <a:buSzPct val="100000"/>
+              <a:buChar char="•"/>
             </a:pPr>
             <a:r>
-              <a:rPr lang="en-US" sz="1250" dirty="0">
+              <a:rPr lang="en-US" sz="1400" dirty="0">
                 <a:solidFill>
-                  <a:srgbClr val="5A6275"/>
+                  <a:srgbClr val="16203F"/>
                 </a:solidFill>
                 <a:latin typeface="Calibri" pitchFamily="34" charset="0"/>
                 <a:ea typeface="Calibri" pitchFamily="34" charset="-122"/>
                 <a:cs typeface="Calibri" pitchFamily="34" charset="-120"/>
               </a:rPr>
-              <a:t>questions answered</a:t>
-            </a:r>
-            <a:endParaRPr lang="en-US" sz="1250" dirty="0"/>
-          </a:p>
-        </p:txBody>
-      </p:sp>
-      <p:sp>
-        <p:nvSpPr>
-          <p:cNvPr id="6" name="Shape 4"/>
-          <p:cNvSpPr/>
-          <p:nvPr/>
-        </p:nvSpPr>
-        <p:spPr>
-          <a:xfrm>
-            <a:off x="3429000" y="1463040"/>
-            <a:ext cx="2606040" cy="1554480"/>
+              <a:t>rageval.py: similarity, ROUGE, BLEU, keyword P/R/F1</a:t>
+            </a:r>
+            <a:endParaRPr lang="en-US" sz="1400" dirty="0"/>
+          </a:p>
+          <a:p>
+            <a:pPr marL="342900" indent="-342900">
+              <a:spcAft>
+                <a:spcPts val="800"/>
+              </a:spcAft>
+              <a:buSzPct val="100000"/>
+              <a:buChar char="•"/>
+            </a:pPr>
+            <a:r>
+              <a:rPr lang="en-US" sz="1400" dirty="0">
+                <a:solidFill>
+                  <a:srgbClr val="16203F"/>
+                </a:solidFill>
+                <a:latin typeface="Calibri" pitchFamily="34" charset="0"/>
+                <a:ea typeface="Calibri" pitchFamily="34" charset="-122"/>
+                <a:cs typeface="Calibri" pitchFamily="34" charset="-120"/>
+              </a:rPr>
+              <a:t>Agent vs plain-RAG baseline, same model &amp; questions</a:t>
+            </a:r>
+            <a:endParaRPr lang="en-US" sz="1400" dirty="0"/>
+          </a:p>
+        </p:txBody>
+      </p:sp>
+      <p:sp>
+        <p:nvSpPr>
+          <p:cNvPr id="9" name="Shape 7"/>
+          <p:cNvSpPr/>
+          <p:nvPr/>
+        </p:nvSpPr>
+        <p:spPr>
+          <a:xfrm>
+            <a:off x="6217920" y="3611880"/>
+            <a:ext cx="5303520" cy="2377440"/>
           </a:xfrm>
           <a:prstGeom prst="rect">
             <a:avLst/>
@@ -6846,14 +8627,14 @@
       </p:sp>
       <p:sp>
         <p:nvSpPr>
-          <p:cNvPr id="7" name="Text 5"/>
-          <p:cNvSpPr/>
-          <p:nvPr/>
-        </p:nvSpPr>
-        <p:spPr>
-          <a:xfrm>
-            <a:off x="3429000" y="1627632"/>
-            <a:ext cx="2606040" cy="822960"/>
+          <p:cNvPr id="10" name="Text 8"/>
+          <p:cNvSpPr/>
+          <p:nvPr/>
+        </p:nvSpPr>
+        <p:spPr>
+          <a:xfrm>
+            <a:off x="6492240" y="3794760"/>
+            <a:ext cx="4754880" cy="457200"/>
           </a:xfrm>
           <a:prstGeom prst="rect">
             <a:avLst/>
@@ -6865,11 +8646,11 @@
           <a:bodyPr wrap="square" rtlCol="0" anchor="ctr"/>
           <a:lstStyle/>
           <a:p>
-            <a:pPr algn="ctr" indent="0" marL="0">
+            <a:pPr indent="0" marL="0">
               <a:buNone/>
             </a:pPr>
             <a:r>
-              <a:rPr lang="en-US" sz="4000" b="1" dirty="0">
+              <a:rPr lang="en-US" sz="1700" b="1" dirty="0">
                 <a:solidFill>
                   <a:srgbClr val="00A896"/>
                 </a:solidFill>
@@ -6877,22 +8658,22 @@
                 <a:ea typeface="Georgia" pitchFamily="34" charset="-122"/>
                 <a:cs typeface="Georgia" pitchFamily="34" charset="-120"/>
               </a:rPr>
-              <a:t>3 / 3</a:t>
-            </a:r>
-            <a:endParaRPr lang="en-US" sz="4000" dirty="0"/>
-          </a:p>
-        </p:txBody>
-      </p:sp>
-      <p:sp>
-        <p:nvSpPr>
-          <p:cNvPr id="8" name="Text 6"/>
-          <p:cNvSpPr/>
-          <p:nvPr/>
-        </p:nvSpPr>
-        <p:spPr>
-          <a:xfrm>
-            <a:off x="3566160" y="2423160"/>
-            <a:ext cx="2331720" cy="502920"/>
+              <a:t>Qualitative</a:t>
+            </a:r>
+            <a:endParaRPr lang="en-US" sz="1700" dirty="0"/>
+          </a:p>
+        </p:txBody>
+      </p:sp>
+      <p:sp>
+        <p:nvSpPr>
+          <p:cNvPr id="11" name="Text 9"/>
+          <p:cNvSpPr/>
+          <p:nvPr/>
+        </p:nvSpPr>
+        <p:spPr>
+          <a:xfrm>
+            <a:off x="6492240" y="4297680"/>
+            <a:ext cx="4754880" cy="1554480"/>
           </a:xfrm>
           <a:prstGeom prst="rect">
             <a:avLst/>
@@ -6904,33 +8685,129 @@
           <a:bodyPr wrap="square" rtlCol="0" anchor="ctr"/>
           <a:lstStyle/>
           <a:p>
-            <a:pPr algn="ctr" indent="0" marL="0">
-              <a:buNone/>
+            <a:pPr marL="342900" indent="-342900">
+              <a:spcAft>
+                <a:spcPts val="800"/>
+              </a:spcAft>
+              <a:buSzPct val="100000"/>
+              <a:buChar char="•"/>
             </a:pPr>
             <a:r>
-              <a:rPr lang="en-US" sz="1250" dirty="0">
+              <a:rPr lang="en-US" sz="1400" dirty="0">
                 <a:solidFill>
-                  <a:srgbClr val="5A6275"/>
+                  <a:srgbClr val="16203F"/>
                 </a:solidFill>
                 <a:latin typeface="Calibri" pitchFamily="34" charset="0"/>
                 <a:ea typeface="Calibri" pitchFamily="34" charset="-122"/>
                 <a:cs typeface="Calibri" pitchFamily="34" charset="-120"/>
               </a:rPr>
-              <a:t>out-of-scope refusals</a:t>
-            </a:r>
-            <a:endParaRPr lang="en-US" sz="1250" dirty="0"/>
-          </a:p>
-        </p:txBody>
-      </p:sp>
-      <p:sp>
-        <p:nvSpPr>
-          <p:cNvPr id="9" name="Shape 7"/>
-          <p:cNvSpPr/>
-          <p:nvPr/>
-        </p:nvSpPr>
-        <p:spPr>
-          <a:xfrm>
-            <a:off x="6217920" y="1463040"/>
+              <a:t>LLM-as-judge: semantic equivalence + confidence</a:t>
+            </a:r>
+            <a:endParaRPr lang="en-US" sz="1400" dirty="0"/>
+          </a:p>
+          <a:p>
+            <a:pPr marL="342900" indent="-342900">
+              <a:spcAft>
+                <a:spcPts val="800"/>
+              </a:spcAft>
+              <a:buSzPct val="100000"/>
+              <a:buChar char="•"/>
+            </a:pPr>
+            <a:r>
+              <a:rPr lang="en-US" sz="1400" dirty="0">
+                <a:solidFill>
+                  <a:srgbClr val="16203F"/>
+                </a:solidFill>
+                <a:latin typeface="Calibri" pitchFamily="34" charset="0"/>
+                <a:ea typeface="Calibri" pitchFamily="34" charset="-122"/>
+                <a:cs typeface="Calibri" pitchFamily="34" charset="-120"/>
+              </a:rPr>
+              <a:t>Refusal accuracy + error analysis by category</a:t>
+            </a:r>
+            <a:endParaRPr lang="en-US" sz="1400" dirty="0"/>
+          </a:p>
+        </p:txBody>
+      </p:sp>
+    </p:spTree>
+  </p:cSld>
+  <p:clrMapOvr>
+    <a:masterClrMapping/>
+  </p:clrMapOvr>
+</p:sld>
+</file>
+
+<file path=ppt/slides/slide9.xml><?xml version="1.0" encoding="utf-8"?>
+<p:sld xmlns:a="http://schemas.openxmlformats.org/drawingml/2006/main" xmlns:r="http://schemas.openxmlformats.org/officeDocument/2006/relationships" xmlns:p="http://schemas.openxmlformats.org/presentationml/2006/main">
+  <p:cSld name="Slide 9">
+    <p:bg>
+      <p:bgPr>
+        <a:solidFill>
+          <a:srgbClr val="FFFFFF"/>
+        </a:solidFill>
+      </p:bgPr>
+    </p:bg>
+    <p:spTree>
+      <p:nvGrpSpPr>
+        <p:cNvPr id="1" name=""/>
+        <p:cNvGrpSpPr/>
+        <p:nvPr/>
+      </p:nvGrpSpPr>
+      <p:grpSpPr>
+        <a:xfrm>
+          <a:off x="0" y="0"/>
+          <a:ext cx="0" cy="0"/>
+          <a:chOff x="0" y="0"/>
+          <a:chExt cx="0" cy="0"/>
+        </a:xfrm>
+      </p:grpSpPr>
+      <p:sp>
+        <p:nvSpPr>
+          <p:cNvPr id="2" name="Text 0"/>
+          <p:cNvSpPr/>
+          <p:nvPr/>
+        </p:nvSpPr>
+        <p:spPr>
+          <a:xfrm>
+            <a:off x="640080" y="411480"/>
+            <a:ext cx="10972800" cy="731520"/>
+          </a:xfrm>
+          <a:prstGeom prst="rect">
+            <a:avLst/>
+          </a:prstGeom>
+          <a:noFill/>
+          <a:ln/>
+        </p:spPr>
+        <p:txBody>
+          <a:bodyPr wrap="square" rtlCol="0" anchor="ctr"/>
+          <a:lstStyle/>
+          <a:p>
+            <a:pPr indent="0" marL="0">
+              <a:buNone/>
+            </a:pPr>
+            <a:r>
+              <a:rPr lang="en-US" sz="3000" b="1" dirty="0">
+                <a:solidFill>
+                  <a:srgbClr val="1E2761"/>
+                </a:solidFill>
+                <a:latin typeface="Georgia" pitchFamily="34" charset="0"/>
+                <a:ea typeface="Georgia" pitchFamily="34" charset="-122"/>
+                <a:cs typeface="Georgia" pitchFamily="34" charset="-120"/>
+              </a:rPr>
+              <a:t>Results</a:t>
+            </a:r>
+            <a:endParaRPr lang="en-US" sz="3000" dirty="0"/>
+          </a:p>
+        </p:txBody>
+      </p:sp>
+      <p:sp>
+        <p:nvSpPr>
+          <p:cNvPr id="3" name="Shape 1"/>
+          <p:cNvSpPr/>
+          <p:nvPr/>
+        </p:nvSpPr>
+        <p:spPr>
+          <a:xfrm>
+            <a:off x="640080" y="1463040"/>
             <a:ext cx="2606040" cy="1554480"/>
           </a:xfrm>
           <a:prstGeom prst="rect">
@@ -6956,13 +8833,13 @@
       </p:sp>
       <p:sp>
         <p:nvSpPr>
-          <p:cNvPr id="10" name="Text 8"/>
-          <p:cNvSpPr/>
-          <p:nvPr/>
-        </p:nvSpPr>
-        <p:spPr>
-          <a:xfrm>
-            <a:off x="6217920" y="1627632"/>
+          <p:cNvPr id="4" name="Text 2"/>
+          <p:cNvSpPr/>
+          <p:nvPr/>
+        </p:nvSpPr>
+        <p:spPr>
+          <a:xfrm>
+            <a:off x="640080" y="1627632"/>
             <a:ext cx="2606040" cy="822960"/>
           </a:xfrm>
           <a:prstGeom prst="rect">
@@ -6987,7 +8864,7 @@
                 <a:ea typeface="Georgia" pitchFamily="34" charset="-122"/>
                 <a:cs typeface="Georgia" pitchFamily="34" charset="-120"/>
               </a:rPr>
-              <a:t>79%</a:t>
+              <a:t>30 / 30</a:t>
             </a:r>
             <a:endParaRPr lang="en-US" sz="4000" dirty="0"/>
           </a:p>
@@ -6995,13 +8872,13 @@
       </p:sp>
       <p:sp>
         <p:nvSpPr>
-          <p:cNvPr id="11" name="Text 9"/>
-          <p:cNvSpPr/>
-          <p:nvPr/>
-        </p:nvSpPr>
-        <p:spPr>
-          <a:xfrm>
-            <a:off x="6355080" y="2423160"/>
+          <p:cNvPr id="5" name="Text 3"/>
+          <p:cNvSpPr/>
+          <p:nvPr/>
+        </p:nvSpPr>
+        <p:spPr>
+          <a:xfrm>
+            <a:off x="777240" y="2423160"/>
             <a:ext cx="2331720" cy="502920"/>
           </a:xfrm>
           <a:prstGeom prst="rect">
@@ -7026,7 +8903,7 @@
                 <a:ea typeface="Calibri" pitchFamily="34" charset="-122"/>
                 <a:cs typeface="Calibri" pitchFamily="34" charset="-120"/>
               </a:rPr>
-              <a:t>LLM-judge: equivalent</a:t>
+              <a:t>questions answered</a:t>
             </a:r>
             <a:endParaRPr lang="en-US" sz="1250" dirty="0"/>
           </a:p>
@@ -7034,14 +8911,14 @@
       </p:sp>
       <p:sp>
         <p:nvSpPr>
-          <p:cNvPr id="12" name="Shape 10"/>
-          <p:cNvSpPr/>
-          <p:nvPr/>
-        </p:nvSpPr>
-        <p:spPr>
-          <a:xfrm>
-            <a:off x="9006840" y="1463040"/>
-            <a:ext cx="2514600" cy="1554480"/>
+          <p:cNvPr id="6" name="Shape 4"/>
+          <p:cNvSpPr/>
+          <p:nvPr/>
+        </p:nvSpPr>
+        <p:spPr>
+          <a:xfrm>
+            <a:off x="3429000" y="1463040"/>
+            <a:ext cx="2606040" cy="1554480"/>
           </a:xfrm>
           <a:prstGeom prst="rect">
             <a:avLst/>
@@ -7066,14 +8943,14 @@
       </p:sp>
       <p:sp>
         <p:nvSpPr>
-          <p:cNvPr id="13" name="Text 11"/>
-          <p:cNvSpPr/>
-          <p:nvPr/>
-        </p:nvSpPr>
-        <p:spPr>
-          <a:xfrm>
-            <a:off x="9006840" y="1627632"/>
-            <a:ext cx="2514600" cy="822960"/>
+          <p:cNvPr id="7" name="Text 5"/>
+          <p:cNvSpPr/>
+          <p:nvPr/>
+        </p:nvSpPr>
+        <p:spPr>
+          <a:xfrm>
+            <a:off x="3429000" y="1627632"/>
+            <a:ext cx="2606040" cy="822960"/>
           </a:xfrm>
           <a:prstGeom prst="rect">
             <a:avLst/>
@@ -7097,7 +8974,7 @@
                 <a:ea typeface="Georgia" pitchFamily="34" charset="-122"/>
                 <a:cs typeface="Georgia" pitchFamily="34" charset="-120"/>
               </a:rPr>
-              <a:t>0.97</a:t>
+              <a:t>3 / 3</a:t>
             </a:r>
             <a:endParaRPr lang="en-US" sz="4000" dirty="0"/>
           </a:p>
@@ -7105,14 +8982,14 @@
       </p:sp>
       <p:sp>
         <p:nvSpPr>
-          <p:cNvPr id="14" name="Text 12"/>
-          <p:cNvSpPr/>
-          <p:nvPr/>
-        </p:nvSpPr>
-        <p:spPr>
-          <a:xfrm>
-            <a:off x="9144000" y="2423160"/>
-            <a:ext cx="2240280" cy="502920"/>
+          <p:cNvPr id="8" name="Text 6"/>
+          <p:cNvSpPr/>
+          <p:nvPr/>
+        </p:nvSpPr>
+        <p:spPr>
+          <a:xfrm>
+            <a:off x="3566160" y="2423160"/>
+            <a:ext cx="2331720" cy="502920"/>
           </a:xfrm>
           <a:prstGeom prst="rect">
             <a:avLst/>
@@ -7136,7 +9013,7 @@
                 <a:ea typeface="Calibri" pitchFamily="34" charset="-122"/>
                 <a:cs typeface="Calibri" pitchFamily="34" charset="-120"/>
               </a:rPr>
-              <a:t>judge confidence</a:t>
+              <a:t>out-of-scope refusals</a:t>
             </a:r>
             <a:endParaRPr lang="en-US" sz="1250" dirty="0"/>
           </a:p>
@@ -7144,14 +9021,14 @@
       </p:sp>
       <p:sp>
         <p:nvSpPr>
-          <p:cNvPr id="15" name="Shape 13"/>
-          <p:cNvSpPr/>
-          <p:nvPr/>
-        </p:nvSpPr>
-        <p:spPr>
-          <a:xfrm>
-            <a:off x="640080" y="3383280"/>
-            <a:ext cx="10881360" cy="2651760"/>
+          <p:cNvPr id="9" name="Shape 7"/>
+          <p:cNvSpPr/>
+          <p:nvPr/>
+        </p:nvSpPr>
+        <p:spPr>
+          <a:xfrm>
+            <a:off x="6217920" y="1463040"/>
+            <a:ext cx="2606040" cy="1554480"/>
           </a:xfrm>
           <a:prstGeom prst="rect">
             <a:avLst/>
@@ -7176,6 +9053,226 @@
       </p:sp>
       <p:sp>
         <p:nvSpPr>
+          <p:cNvPr id="10" name="Text 8"/>
+          <p:cNvSpPr/>
+          <p:nvPr/>
+        </p:nvSpPr>
+        <p:spPr>
+          <a:xfrm>
+            <a:off x="6217920" y="1627632"/>
+            <a:ext cx="2606040" cy="822960"/>
+          </a:xfrm>
+          <a:prstGeom prst="rect">
+            <a:avLst/>
+          </a:prstGeom>
+          <a:noFill/>
+          <a:ln/>
+        </p:spPr>
+        <p:txBody>
+          <a:bodyPr wrap="square" rtlCol="0" anchor="ctr"/>
+          <a:lstStyle/>
+          <a:p>
+            <a:pPr algn="ctr" indent="0" marL="0">
+              <a:buNone/>
+            </a:pPr>
+            <a:r>
+              <a:rPr lang="en-US" sz="4000" b="1" dirty="0">
+                <a:solidFill>
+                  <a:srgbClr val="1E2761"/>
+                </a:solidFill>
+                <a:latin typeface="Georgia" pitchFamily="34" charset="0"/>
+                <a:ea typeface="Georgia" pitchFamily="34" charset="-122"/>
+                <a:cs typeface="Georgia" pitchFamily="34" charset="-120"/>
+              </a:rPr>
+              <a:t>79%</a:t>
+            </a:r>
+            <a:endParaRPr lang="en-US" sz="4000" dirty="0"/>
+          </a:p>
+        </p:txBody>
+      </p:sp>
+      <p:sp>
+        <p:nvSpPr>
+          <p:cNvPr id="11" name="Text 9"/>
+          <p:cNvSpPr/>
+          <p:nvPr/>
+        </p:nvSpPr>
+        <p:spPr>
+          <a:xfrm>
+            <a:off x="6355080" y="2423160"/>
+            <a:ext cx="2331720" cy="502920"/>
+          </a:xfrm>
+          <a:prstGeom prst="rect">
+            <a:avLst/>
+          </a:prstGeom>
+          <a:noFill/>
+          <a:ln/>
+        </p:spPr>
+        <p:txBody>
+          <a:bodyPr wrap="square" rtlCol="0" anchor="ctr"/>
+          <a:lstStyle/>
+          <a:p>
+            <a:pPr algn="ctr" indent="0" marL="0">
+              <a:buNone/>
+            </a:pPr>
+            <a:r>
+              <a:rPr lang="en-US" sz="1250" dirty="0">
+                <a:solidFill>
+                  <a:srgbClr val="5A6275"/>
+                </a:solidFill>
+                <a:latin typeface="Calibri" pitchFamily="34" charset="0"/>
+                <a:ea typeface="Calibri" pitchFamily="34" charset="-122"/>
+                <a:cs typeface="Calibri" pitchFamily="34" charset="-120"/>
+              </a:rPr>
+              <a:t>LLM-judge: equivalent</a:t>
+            </a:r>
+            <a:endParaRPr lang="en-US" sz="1250" dirty="0"/>
+          </a:p>
+        </p:txBody>
+      </p:sp>
+      <p:sp>
+        <p:nvSpPr>
+          <p:cNvPr id="12" name="Shape 10"/>
+          <p:cNvSpPr/>
+          <p:nvPr/>
+        </p:nvSpPr>
+        <p:spPr>
+          <a:xfrm>
+            <a:off x="9006840" y="1463040"/>
+            <a:ext cx="2514600" cy="1554480"/>
+          </a:xfrm>
+          <a:prstGeom prst="rect">
+            <a:avLst/>
+          </a:prstGeom>
+          <a:solidFill>
+            <a:srgbClr val="FFFFFF"/>
+          </a:solidFill>
+          <a:ln w="12700">
+            <a:solidFill>
+              <a:srgbClr val="CADCFC"/>
+            </a:solidFill>
+            <a:prstDash val="solid"/>
+          </a:ln>
+          <a:effectLst>
+            <a:outerShdw sx="100000" sy="100000" kx="0" ky="0" algn="bl" rotWithShape="0" blurRad="76200" dist="25400" dir="8100000">
+              <a:srgbClr val="000000">
+                <a:alpha val="10000"/>
+              </a:srgbClr>
+            </a:outerShdw>
+          </a:effectLst>
+        </p:spPr>
+      </p:sp>
+      <p:sp>
+        <p:nvSpPr>
+          <p:cNvPr id="13" name="Text 11"/>
+          <p:cNvSpPr/>
+          <p:nvPr/>
+        </p:nvSpPr>
+        <p:spPr>
+          <a:xfrm>
+            <a:off x="9006840" y="1627632"/>
+            <a:ext cx="2514600" cy="822960"/>
+          </a:xfrm>
+          <a:prstGeom prst="rect">
+            <a:avLst/>
+          </a:prstGeom>
+          <a:noFill/>
+          <a:ln/>
+        </p:spPr>
+        <p:txBody>
+          <a:bodyPr wrap="square" rtlCol="0" anchor="ctr"/>
+          <a:lstStyle/>
+          <a:p>
+            <a:pPr algn="ctr" indent="0" marL="0">
+              <a:buNone/>
+            </a:pPr>
+            <a:r>
+              <a:rPr lang="en-US" sz="4000" b="1" dirty="0">
+                <a:solidFill>
+                  <a:srgbClr val="00A896"/>
+                </a:solidFill>
+                <a:latin typeface="Georgia" pitchFamily="34" charset="0"/>
+                <a:ea typeface="Georgia" pitchFamily="34" charset="-122"/>
+                <a:cs typeface="Georgia" pitchFamily="34" charset="-120"/>
+              </a:rPr>
+              <a:t>0.97</a:t>
+            </a:r>
+            <a:endParaRPr lang="en-US" sz="4000" dirty="0"/>
+          </a:p>
+        </p:txBody>
+      </p:sp>
+      <p:sp>
+        <p:nvSpPr>
+          <p:cNvPr id="14" name="Text 12"/>
+          <p:cNvSpPr/>
+          <p:nvPr/>
+        </p:nvSpPr>
+        <p:spPr>
+          <a:xfrm>
+            <a:off x="9144000" y="2423160"/>
+            <a:ext cx="2240280" cy="502920"/>
+          </a:xfrm>
+          <a:prstGeom prst="rect">
+            <a:avLst/>
+          </a:prstGeom>
+          <a:noFill/>
+          <a:ln/>
+        </p:spPr>
+        <p:txBody>
+          <a:bodyPr wrap="square" rtlCol="0" anchor="ctr"/>
+          <a:lstStyle/>
+          <a:p>
+            <a:pPr algn="ctr" indent="0" marL="0">
+              <a:buNone/>
+            </a:pPr>
+            <a:r>
+              <a:rPr lang="en-US" sz="1250" dirty="0">
+                <a:solidFill>
+                  <a:srgbClr val="5A6275"/>
+                </a:solidFill>
+                <a:latin typeface="Calibri" pitchFamily="34" charset="0"/>
+                <a:ea typeface="Calibri" pitchFamily="34" charset="-122"/>
+                <a:cs typeface="Calibri" pitchFamily="34" charset="-120"/>
+              </a:rPr>
+              <a:t>judge confidence</a:t>
+            </a:r>
+            <a:endParaRPr lang="en-US" sz="1250" dirty="0"/>
+          </a:p>
+        </p:txBody>
+      </p:sp>
+      <p:sp>
+        <p:nvSpPr>
+          <p:cNvPr id="15" name="Shape 13"/>
+          <p:cNvSpPr/>
+          <p:nvPr/>
+        </p:nvSpPr>
+        <p:spPr>
+          <a:xfrm>
+            <a:off x="640080" y="3383280"/>
+            <a:ext cx="10881360" cy="2651760"/>
+          </a:xfrm>
+          <a:prstGeom prst="rect">
+            <a:avLst/>
+          </a:prstGeom>
+          <a:solidFill>
+            <a:srgbClr val="FFFFFF"/>
+          </a:solidFill>
+          <a:ln w="12700">
+            <a:solidFill>
+              <a:srgbClr val="CADCFC"/>
+            </a:solidFill>
+            <a:prstDash val="solid"/>
+          </a:ln>
+          <a:effectLst>
+            <a:outerShdw sx="100000" sy="100000" kx="0" ky="0" algn="bl" rotWithShape="0" blurRad="76200" dist="25400" dir="8100000">
+              <a:srgbClr val="000000">
+                <a:alpha val="10000"/>
+              </a:srgbClr>
+            </a:outerShdw>
+          </a:effectLst>
+        </p:spPr>
+      </p:sp>
+      <p:sp>
+        <p:nvSpPr>
           <p:cNvPr id="16" name="Text 14"/>
           <p:cNvSpPr/>
           <p:nvPr/>
@@ -7215,7 +9312,7 @@
       </p:sp>
       <p:graphicFrame>
         <p:nvGraphicFramePr>
-          <p:cNvPr id="9" name="Table 0"/>
+          <p:cNvPr id="10" name="Table 0"/>
           <p:cNvGraphicFramePr>
             <a:graphicFrameLocks noGrp="1"/>
           </p:cNvGraphicFramePr>
@@ -8435,485 +10532,6 @@
           </a:graphicData>
         </a:graphic>
       </p:graphicFrame>
-    </p:spTree>
-  </p:cSld>
-  <p:clrMapOvr>
-    <a:masterClrMapping/>
-  </p:clrMapOvr>
-</p:sld>
-</file>
-
-<file path=ppt/slides/slide9.xml><?xml version="1.0" encoding="utf-8"?>
-<p:sld xmlns:a="http://schemas.openxmlformats.org/drawingml/2006/main" xmlns:r="http://schemas.openxmlformats.org/officeDocument/2006/relationships" xmlns:p="http://schemas.openxmlformats.org/presentationml/2006/main">
-  <p:cSld name="Slide 9">
-    <p:bg>
-      <p:bgPr>
-        <a:solidFill>
-          <a:srgbClr val="FFFFFF"/>
-        </a:solidFill>
-      </p:bgPr>
-    </p:bg>
-    <p:spTree>
-      <p:nvGrpSpPr>
-        <p:cNvPr id="1" name=""/>
-        <p:cNvGrpSpPr/>
-        <p:nvPr/>
-      </p:nvGrpSpPr>
-      <p:grpSpPr>
-        <a:xfrm>
-          <a:off x="0" y="0"/>
-          <a:ext cx="0" cy="0"/>
-          <a:chOff x="0" y="0"/>
-          <a:chExt cx="0" cy="0"/>
-        </a:xfrm>
-      </p:grpSpPr>
-      <p:sp>
-        <p:nvSpPr>
-          <p:cNvPr id="2" name="Text 0"/>
-          <p:cNvSpPr/>
-          <p:nvPr/>
-        </p:nvSpPr>
-        <p:spPr>
-          <a:xfrm>
-            <a:off x="640080" y="411480"/>
-            <a:ext cx="10972800" cy="731520"/>
-          </a:xfrm>
-          <a:prstGeom prst="rect">
-            <a:avLst/>
-          </a:prstGeom>
-          <a:noFill/>
-          <a:ln/>
-        </p:spPr>
-        <p:txBody>
-          <a:bodyPr wrap="square" rtlCol="0" anchor="ctr"/>
-          <a:lstStyle/>
-          <a:p>
-            <a:pPr indent="0" marL="0">
-              <a:buNone/>
-            </a:pPr>
-            <a:r>
-              <a:rPr lang="en-US" sz="3000" b="1" dirty="0">
-                <a:solidFill>
-                  <a:srgbClr val="1E2761"/>
-                </a:solidFill>
-                <a:latin typeface="Georgia" pitchFamily="34" charset="0"/>
-                <a:ea typeface="Georgia" pitchFamily="34" charset="-122"/>
-                <a:cs typeface="Georgia" pitchFamily="34" charset="-120"/>
-              </a:rPr>
-              <a:t>Reading the metrics honestly</a:t>
-            </a:r>
-            <a:endParaRPr lang="en-US" sz="3000" dirty="0"/>
-          </a:p>
-        </p:txBody>
-      </p:sp>
-      <p:sp>
-        <p:nvSpPr>
-          <p:cNvPr id="3" name="Shape 1"/>
-          <p:cNvSpPr/>
-          <p:nvPr/>
-        </p:nvSpPr>
-        <p:spPr>
-          <a:xfrm>
-            <a:off x="640080" y="1463040"/>
-            <a:ext cx="10881360" cy="1828800"/>
-          </a:xfrm>
-          <a:prstGeom prst="rect">
-            <a:avLst/>
-          </a:prstGeom>
-          <a:solidFill>
-            <a:srgbClr val="F4F7FB"/>
-          </a:solidFill>
-          <a:ln w="12700">
-            <a:solidFill>
-              <a:srgbClr val="CADCFC"/>
-            </a:solidFill>
-            <a:prstDash val="solid"/>
-          </a:ln>
-          <a:effectLst>
-            <a:outerShdw sx="100000" sy="100000" kx="0" ky="0" algn="bl" rotWithShape="0" blurRad="76200" dist="25400" dir="8100000">
-              <a:srgbClr val="000000">
-                <a:alpha val="10000"/>
-              </a:srgbClr>
-            </a:outerShdw>
-          </a:effectLst>
-        </p:spPr>
-      </p:sp>
-      <p:sp>
-        <p:nvSpPr>
-          <p:cNvPr id="4" name="Text 2"/>
-          <p:cNvSpPr/>
-          <p:nvPr/>
-        </p:nvSpPr>
-        <p:spPr>
-          <a:xfrm>
-            <a:off x="914400" y="1645920"/>
-            <a:ext cx="10332720" cy="457200"/>
-          </a:xfrm>
-          <a:prstGeom prst="rect">
-            <a:avLst/>
-          </a:prstGeom>
-          <a:noFill/>
-          <a:ln/>
-        </p:spPr>
-        <p:txBody>
-          <a:bodyPr wrap="square" rtlCol="0" anchor="ctr"/>
-          <a:lstStyle/>
-          <a:p>
-            <a:pPr indent="0" marL="0">
-              <a:buNone/>
-            </a:pPr>
-            <a:r>
-              <a:rPr lang="en-US" sz="1700" b="1" dirty="0">
-                <a:solidFill>
-                  <a:srgbClr val="1E2761"/>
-                </a:solidFill>
-                <a:latin typeface="Georgia" pitchFamily="34" charset="0"/>
-                <a:ea typeface="Georgia" pitchFamily="34" charset="-122"/>
-                <a:cs typeface="Georgia" pitchFamily="34" charset="-120"/>
-              </a:rPr>
-              <a:t>Why overlap scores look low even when answers are correct</a:t>
-            </a:r>
-            <a:endParaRPr lang="en-US" sz="1700" dirty="0"/>
-          </a:p>
-        </p:txBody>
-      </p:sp>
-      <p:sp>
-        <p:nvSpPr>
-          <p:cNvPr id="5" name="Text 3"/>
-          <p:cNvSpPr/>
-          <p:nvPr/>
-        </p:nvSpPr>
-        <p:spPr>
-          <a:xfrm>
-            <a:off x="914400" y="2148840"/>
-            <a:ext cx="10332720" cy="1005840"/>
-          </a:xfrm>
-          <a:prstGeom prst="rect">
-            <a:avLst/>
-          </a:prstGeom>
-          <a:noFill/>
-          <a:ln/>
-        </p:spPr>
-        <p:txBody>
-          <a:bodyPr wrap="square" rtlCol="0" anchor="ctr"/>
-          <a:lstStyle/>
-          <a:p>
-            <a:pPr indent="0" marL="0">
-              <a:buNone/>
-            </a:pPr>
-            <a:r>
-              <a:rPr lang="en-US" sz="1500" dirty="0">
-                <a:solidFill>
-                  <a:srgbClr val="16203F"/>
-                </a:solidFill>
-                <a:latin typeface="Calibri" pitchFamily="34" charset="0"/>
-                <a:ea typeface="Calibri" pitchFamily="34" charset="-122"/>
-                <a:cs typeface="Calibri" pitchFamily="34" charset="-120"/>
-              </a:rPr>
-              <a:t>Reference answers are one line; the agent gives a full, cited explanation. ROUGE/BLEU reward brevity and exact wording, so extra correct words lower the score.</a:t>
-            </a:r>
-            <a:endParaRPr lang="en-US" sz="1500" dirty="0"/>
-          </a:p>
-        </p:txBody>
-      </p:sp>
-      <p:sp>
-        <p:nvSpPr>
-          <p:cNvPr id="6" name="Shape 4"/>
-          <p:cNvSpPr/>
-          <p:nvPr/>
-        </p:nvSpPr>
-        <p:spPr>
-          <a:xfrm>
-            <a:off x="640080" y="3474720"/>
-            <a:ext cx="5303520" cy="2468880"/>
-          </a:xfrm>
-          <a:prstGeom prst="rect">
-            <a:avLst/>
-          </a:prstGeom>
-          <a:solidFill>
-            <a:srgbClr val="FFFFFF"/>
-          </a:solidFill>
-          <a:ln w="12700">
-            <a:solidFill>
-              <a:srgbClr val="CADCFC"/>
-            </a:solidFill>
-            <a:prstDash val="solid"/>
-          </a:ln>
-          <a:effectLst>
-            <a:outerShdw sx="100000" sy="100000" kx="0" ky="0" algn="bl" rotWithShape="0" blurRad="76200" dist="25400" dir="8100000">
-              <a:srgbClr val="000000">
-                <a:alpha val="10000"/>
-              </a:srgbClr>
-            </a:outerShdw>
-          </a:effectLst>
-        </p:spPr>
-      </p:sp>
-      <p:sp>
-        <p:nvSpPr>
-          <p:cNvPr id="7" name="Text 5"/>
-          <p:cNvSpPr/>
-          <p:nvPr/>
-        </p:nvSpPr>
-        <p:spPr>
-          <a:xfrm>
-            <a:off x="914400" y="3657600"/>
-            <a:ext cx="4754880" cy="365760"/>
-          </a:xfrm>
-          <a:prstGeom prst="rect">
-            <a:avLst/>
-          </a:prstGeom>
-          <a:noFill/>
-          <a:ln/>
-        </p:spPr>
-        <p:txBody>
-          <a:bodyPr wrap="square" rtlCol="0" anchor="ctr"/>
-          <a:lstStyle/>
-          <a:p>
-            <a:pPr indent="0" marL="0">
-              <a:buNone/>
-            </a:pPr>
-            <a:r>
-              <a:rPr lang="en-US" sz="1300" dirty="0">
-                <a:solidFill>
-                  <a:srgbClr val="5A6275"/>
-                </a:solidFill>
-                <a:latin typeface="Calibri" pitchFamily="34" charset="0"/>
-                <a:ea typeface="Calibri" pitchFamily="34" charset="-122"/>
-                <a:cs typeface="Calibri" pitchFamily="34" charset="-120"/>
-              </a:rPr>
-              <a:t>The telling number</a:t>
-            </a:r>
-            <a:endParaRPr lang="en-US" sz="1300" dirty="0"/>
-          </a:p>
-        </p:txBody>
-      </p:sp>
-      <p:sp>
-        <p:nvSpPr>
-          <p:cNvPr id="8" name="Text 6"/>
-          <p:cNvSpPr/>
-          <p:nvPr/>
-        </p:nvSpPr>
-        <p:spPr>
-          <a:xfrm>
-            <a:off x="914400" y="4023360"/>
-            <a:ext cx="4754880" cy="822960"/>
-          </a:xfrm>
-          <a:prstGeom prst="rect">
-            <a:avLst/>
-          </a:prstGeom>
-          <a:noFill/>
-          <a:ln/>
-        </p:spPr>
-        <p:txBody>
-          <a:bodyPr wrap="square" rtlCol="0" anchor="ctr"/>
-          <a:lstStyle/>
-          <a:p>
-            <a:pPr indent="0" marL="0">
-              <a:buNone/>
-            </a:pPr>
-            <a:r>
-              <a:rPr lang="en-US" sz="3000" b="1" dirty="0">
-                <a:solidFill>
-                  <a:srgbClr val="00A896"/>
-                </a:solidFill>
-                <a:latin typeface="Georgia" pitchFamily="34" charset="0"/>
-                <a:ea typeface="Georgia" pitchFamily="34" charset="-122"/>
-                <a:cs typeface="Georgia" pitchFamily="34" charset="-120"/>
-              </a:rPr>
-              <a:t>Keyword recall 0.74</a:t>
-            </a:r>
-            <a:endParaRPr lang="en-US" sz="3000" dirty="0"/>
-          </a:p>
-        </p:txBody>
-      </p:sp>
-      <p:sp>
-        <p:nvSpPr>
-          <p:cNvPr id="9" name="Text 7"/>
-          <p:cNvSpPr/>
-          <p:nvPr/>
-        </p:nvSpPr>
-        <p:spPr>
-          <a:xfrm>
-            <a:off x="914400" y="4937760"/>
-            <a:ext cx="4754880" cy="914400"/>
-          </a:xfrm>
-          <a:prstGeom prst="rect">
-            <a:avLst/>
-          </a:prstGeom>
-          <a:noFill/>
-          <a:ln/>
-        </p:spPr>
-        <p:txBody>
-          <a:bodyPr wrap="square" rtlCol="0" anchor="ctr"/>
-          <a:lstStyle/>
-          <a:p>
-            <a:pPr indent="0" marL="0">
-              <a:buNone/>
-            </a:pPr>
-            <a:r>
-              <a:rPr lang="en-US" sz="1350" dirty="0">
-                <a:solidFill>
-                  <a:srgbClr val="16203F"/>
-                </a:solidFill>
-                <a:latin typeface="Calibri" pitchFamily="34" charset="0"/>
-                <a:ea typeface="Calibri" pitchFamily="34" charset="-122"/>
-                <a:cs typeface="Calibri" pitchFamily="34" charset="-120"/>
-              </a:rPr>
-              <a:t>The agent's answers contain the right content — they are just fuller than the references.</a:t>
-            </a:r>
-            <a:endParaRPr lang="en-US" sz="1350" dirty="0"/>
-          </a:p>
-        </p:txBody>
-      </p:sp>
-      <p:sp>
-        <p:nvSpPr>
-          <p:cNvPr id="10" name="Shape 8"/>
-          <p:cNvSpPr/>
-          <p:nvPr/>
-        </p:nvSpPr>
-        <p:spPr>
-          <a:xfrm>
-            <a:off x="6217920" y="3474720"/>
-            <a:ext cx="5303520" cy="2468880"/>
-          </a:xfrm>
-          <a:prstGeom prst="rect">
-            <a:avLst/>
-          </a:prstGeom>
-          <a:solidFill>
-            <a:srgbClr val="FFFFFF"/>
-          </a:solidFill>
-          <a:ln w="12700">
-            <a:solidFill>
-              <a:srgbClr val="CADCFC"/>
-            </a:solidFill>
-            <a:prstDash val="solid"/>
-          </a:ln>
-          <a:effectLst>
-            <a:outerShdw sx="100000" sy="100000" kx="0" ky="0" algn="bl" rotWithShape="0" blurRad="76200" dist="25400" dir="8100000">
-              <a:srgbClr val="000000">
-                <a:alpha val="10000"/>
-              </a:srgbClr>
-            </a:outerShdw>
-          </a:effectLst>
-        </p:spPr>
-      </p:sp>
-      <p:sp>
-        <p:nvSpPr>
-          <p:cNvPr id="11" name="Text 9"/>
-          <p:cNvSpPr/>
-          <p:nvPr/>
-        </p:nvSpPr>
-        <p:spPr>
-          <a:xfrm>
-            <a:off x="6492240" y="3657600"/>
-            <a:ext cx="4754880" cy="365760"/>
-          </a:xfrm>
-          <a:prstGeom prst="rect">
-            <a:avLst/>
-          </a:prstGeom>
-          <a:noFill/>
-          <a:ln/>
-        </p:spPr>
-        <p:txBody>
-          <a:bodyPr wrap="square" rtlCol="0" anchor="ctr"/>
-          <a:lstStyle/>
-          <a:p>
-            <a:pPr indent="0" marL="0">
-              <a:buNone/>
-            </a:pPr>
-            <a:r>
-              <a:rPr lang="en-US" sz="1300" dirty="0">
-                <a:solidFill>
-                  <a:srgbClr val="5A6275"/>
-                </a:solidFill>
-                <a:latin typeface="Calibri" pitchFamily="34" charset="0"/>
-                <a:ea typeface="Calibri" pitchFamily="34" charset="-122"/>
-                <a:cs typeface="Calibri" pitchFamily="34" charset="-120"/>
-              </a:rPr>
-              <a:t>So we also judge meaning</a:t>
-            </a:r>
-            <a:endParaRPr lang="en-US" sz="1300" dirty="0"/>
-          </a:p>
-        </p:txBody>
-      </p:sp>
-      <p:sp>
-        <p:nvSpPr>
-          <p:cNvPr id="12" name="Text 10"/>
-          <p:cNvSpPr/>
-          <p:nvPr/>
-        </p:nvSpPr>
-        <p:spPr>
-          <a:xfrm>
-            <a:off x="6492240" y="4023360"/>
-            <a:ext cx="4754880" cy="640080"/>
-          </a:xfrm>
-          <a:prstGeom prst="rect">
-            <a:avLst/>
-          </a:prstGeom>
-          <a:noFill/>
-          <a:ln/>
-        </p:spPr>
-        <p:txBody>
-          <a:bodyPr wrap="square" rtlCol="0" anchor="ctr"/>
-          <a:lstStyle/>
-          <a:p>
-            <a:pPr indent="0" marL="0">
-              <a:buNone/>
-            </a:pPr>
-            <a:r>
-              <a:rPr lang="en-US" sz="2600" b="1" dirty="0">
-                <a:solidFill>
-                  <a:srgbClr val="1E2761"/>
-                </a:solidFill>
-                <a:latin typeface="Georgia" pitchFamily="34" charset="0"/>
-                <a:ea typeface="Georgia" pitchFamily="34" charset="-122"/>
-                <a:cs typeface="Georgia" pitchFamily="34" charset="-120"/>
-              </a:rPr>
-              <a:t>LLM-as-judge</a:t>
-            </a:r>
-            <a:endParaRPr lang="en-US" sz="2600" dirty="0"/>
-          </a:p>
-        </p:txBody>
-      </p:sp>
-      <p:sp>
-        <p:nvSpPr>
-          <p:cNvPr id="13" name="Text 11"/>
-          <p:cNvSpPr/>
-          <p:nvPr/>
-        </p:nvSpPr>
-        <p:spPr>
-          <a:xfrm>
-            <a:off x="6492240" y="4754880"/>
-            <a:ext cx="4754880" cy="1097280"/>
-          </a:xfrm>
-          <a:prstGeom prst="rect">
-            <a:avLst/>
-          </a:prstGeom>
-          <a:noFill/>
-          <a:ln/>
-        </p:spPr>
-        <p:txBody>
-          <a:bodyPr wrap="square" rtlCol="0" anchor="ctr"/>
-          <a:lstStyle/>
-          <a:p>
-            <a:pPr indent="0" marL="0">
-              <a:buNone/>
-            </a:pPr>
-            <a:r>
-              <a:rPr lang="en-US" sz="1350" dirty="0">
-                <a:solidFill>
-                  <a:srgbClr val="16203F"/>
-                </a:solidFill>
-                <a:latin typeface="Calibri" pitchFamily="34" charset="0"/>
-                <a:ea typeface="Calibri" pitchFamily="34" charset="-122"/>
-                <a:cs typeface="Calibri" pitchFamily="34" charset="-120"/>
-              </a:rPr>
-              <a:t>Scores semantic equivalence rather than word overlap — the fairer measure for cited, explanatory answers.</a:t>
-            </a:r>
-            <a:endParaRPr lang="en-US" sz="1350" dirty="0"/>
-          </a:p>
-        </p:txBody>
-      </p:sp>
     </p:spTree>
   </p:cSld>
   <p:clrMapOvr>

</xml_diff>